<commit_message>
Updates in Chapter 3
</commit_message>
<xml_diff>
--- a/figures/figures.pptx
+++ b/figures/figures.pptx
@@ -5,28 +5,29 @@
     <p:sldMasterId id="2147483648" r:id="rId1"/>
   </p:sldMasterIdLst>
   <p:notesMasterIdLst>
-    <p:notesMasterId r:id="rId21"/>
+    <p:notesMasterId r:id="rId22"/>
   </p:notesMasterIdLst>
   <p:sldIdLst>
     <p:sldId id="256" r:id="rId2"/>
-    <p:sldId id="257" r:id="rId3"/>
-    <p:sldId id="258" r:id="rId4"/>
-    <p:sldId id="272" r:id="rId5"/>
-    <p:sldId id="273" r:id="rId6"/>
-    <p:sldId id="275" r:id="rId7"/>
-    <p:sldId id="274" r:id="rId8"/>
-    <p:sldId id="268" r:id="rId9"/>
-    <p:sldId id="269" r:id="rId10"/>
-    <p:sldId id="260" r:id="rId11"/>
-    <p:sldId id="263" r:id="rId12"/>
-    <p:sldId id="261" r:id="rId13"/>
-    <p:sldId id="270" r:id="rId14"/>
-    <p:sldId id="262" r:id="rId15"/>
-    <p:sldId id="265" r:id="rId16"/>
-    <p:sldId id="266" r:id="rId17"/>
-    <p:sldId id="267" r:id="rId18"/>
-    <p:sldId id="271" r:id="rId19"/>
-    <p:sldId id="276" r:id="rId20"/>
+    <p:sldId id="277" r:id="rId3"/>
+    <p:sldId id="257" r:id="rId4"/>
+    <p:sldId id="258" r:id="rId5"/>
+    <p:sldId id="272" r:id="rId6"/>
+    <p:sldId id="273" r:id="rId7"/>
+    <p:sldId id="275" r:id="rId8"/>
+    <p:sldId id="274" r:id="rId9"/>
+    <p:sldId id="268" r:id="rId10"/>
+    <p:sldId id="269" r:id="rId11"/>
+    <p:sldId id="260" r:id="rId12"/>
+    <p:sldId id="263" r:id="rId13"/>
+    <p:sldId id="261" r:id="rId14"/>
+    <p:sldId id="270" r:id="rId15"/>
+    <p:sldId id="262" r:id="rId16"/>
+    <p:sldId id="265" r:id="rId17"/>
+    <p:sldId id="266" r:id="rId18"/>
+    <p:sldId id="267" r:id="rId19"/>
+    <p:sldId id="271" r:id="rId20"/>
+    <p:sldId id="276" r:id="rId21"/>
   </p:sldIdLst>
   <p:sldSz cx="12192000" cy="6858000"/>
   <p:notesSz cx="6858000" cy="9144000"/>
@@ -2912,7 +2913,7 @@
           <a:p>
             <a:fld id="{8CF8B62D-F47B-43DC-854F-884833B98021}" type="datetimeFigureOut">
               <a:rPr lang="de-DE" smtClean="0"/>
-              <a:t>25.08.2025</a:t>
+              <a:t>28.08.2025</a:t>
             </a:fld>
             <a:endParaRPr lang="de-DE"/>
           </a:p>
@@ -3245,7 +3246,7 @@
           <a:p>
             <a:fld id="{AB2C2533-D42D-4AF8-9C02-1BDA65857909}" type="slidenum">
               <a:rPr lang="de-DE" smtClean="0"/>
-              <a:t>10</a:t>
+              <a:t>11</a:t>
             </a:fld>
             <a:endParaRPr lang="de-DE"/>
           </a:p>
@@ -3329,7 +3330,7 @@
           <a:p>
             <a:fld id="{AB2C2533-D42D-4AF8-9C02-1BDA65857909}" type="slidenum">
               <a:rPr lang="de-DE" smtClean="0"/>
-              <a:t>15</a:t>
+              <a:t>16</a:t>
             </a:fld>
             <a:endParaRPr lang="de-DE"/>
           </a:p>
@@ -3339,6 +3340,90 @@
     <p:extLst>
       <p:ext uri="{BB962C8B-B14F-4D97-AF65-F5344CB8AC3E}">
         <p14:creationId xmlns:p14="http://schemas.microsoft.com/office/powerpoint/2010/main" val="2965620531"/>
+      </p:ext>
+    </p:extLst>
+  </p:cSld>
+  <p:clrMapOvr>
+    <a:masterClrMapping/>
+  </p:clrMapOvr>
+</p:notes>
+</file>
+
+<file path=ppt/notesSlides/notesSlide3.xml><?xml version="1.0" encoding="utf-8"?>
+<p:notes xmlns:a="http://schemas.openxmlformats.org/drawingml/2006/main" xmlns:r="http://schemas.openxmlformats.org/officeDocument/2006/relationships" xmlns:p="http://schemas.openxmlformats.org/presentationml/2006/main">
+  <p:cSld>
+    <p:spTree>
+      <p:nvGrpSpPr>
+        <p:cNvPr id="1" name=""/>
+        <p:cNvGrpSpPr/>
+        <p:nvPr/>
+      </p:nvGrpSpPr>
+      <p:grpSpPr>
+        <a:xfrm>
+          <a:off x="0" y="0"/>
+          <a:ext cx="0" cy="0"/>
+          <a:chOff x="0" y="0"/>
+          <a:chExt cx="0" cy="0"/>
+        </a:xfrm>
+      </p:grpSpPr>
+      <p:sp>
+        <p:nvSpPr>
+          <p:cNvPr id="2" name="Slide Image Placeholder 1"/>
+          <p:cNvSpPr>
+            <a:spLocks noGrp="1" noRot="1" noChangeAspect="1"/>
+          </p:cNvSpPr>
+          <p:nvPr>
+            <p:ph type="sldImg"/>
+          </p:nvPr>
+        </p:nvSpPr>
+        <p:spPr/>
+      </p:sp>
+      <p:sp>
+        <p:nvSpPr>
+          <p:cNvPr id="3" name="Notes Placeholder 2"/>
+          <p:cNvSpPr>
+            <a:spLocks noGrp="1"/>
+          </p:cNvSpPr>
+          <p:nvPr>
+            <p:ph type="body" idx="1"/>
+          </p:nvPr>
+        </p:nvSpPr>
+        <p:spPr/>
+        <p:txBody>
+          <a:bodyPr/>
+          <a:lstStyle/>
+          <a:p>
+            <a:endParaRPr lang="de-DE" dirty="0"/>
+          </a:p>
+        </p:txBody>
+      </p:sp>
+      <p:sp>
+        <p:nvSpPr>
+          <p:cNvPr id="4" name="Slide Number Placeholder 3"/>
+          <p:cNvSpPr>
+            <a:spLocks noGrp="1"/>
+          </p:cNvSpPr>
+          <p:nvPr>
+            <p:ph type="sldNum" sz="quarter" idx="5"/>
+          </p:nvPr>
+        </p:nvSpPr>
+        <p:spPr/>
+        <p:txBody>
+          <a:bodyPr/>
+          <a:lstStyle/>
+          <a:p>
+            <a:fld id="{AB2C2533-D42D-4AF8-9C02-1BDA65857909}" type="slidenum">
+              <a:rPr lang="de-DE" smtClean="0"/>
+              <a:t>20</a:t>
+            </a:fld>
+            <a:endParaRPr lang="de-DE"/>
+          </a:p>
+        </p:txBody>
+      </p:sp>
+    </p:spTree>
+    <p:extLst>
+      <p:ext uri="{BB962C8B-B14F-4D97-AF65-F5344CB8AC3E}">
+        <p14:creationId xmlns:p14="http://schemas.microsoft.com/office/powerpoint/2010/main" val="3640143401"/>
       </p:ext>
     </p:extLst>
   </p:cSld>
@@ -3497,7 +3582,7 @@
           <a:p>
             <a:fld id="{3146589B-F63A-42CD-B487-02649808258F}" type="datetimeFigureOut">
               <a:rPr lang="de-DE" smtClean="0"/>
-              <a:t>25.08.2025</a:t>
+              <a:t>28.08.2025</a:t>
             </a:fld>
             <a:endParaRPr lang="de-DE"/>
           </a:p>
@@ -3697,7 +3782,7 @@
           <a:p>
             <a:fld id="{3146589B-F63A-42CD-B487-02649808258F}" type="datetimeFigureOut">
               <a:rPr lang="de-DE" smtClean="0"/>
-              <a:t>25.08.2025</a:t>
+              <a:t>28.08.2025</a:t>
             </a:fld>
             <a:endParaRPr lang="de-DE"/>
           </a:p>
@@ -3907,7 +3992,7 @@
           <a:p>
             <a:fld id="{3146589B-F63A-42CD-B487-02649808258F}" type="datetimeFigureOut">
               <a:rPr lang="de-DE" smtClean="0"/>
-              <a:t>25.08.2025</a:t>
+              <a:t>28.08.2025</a:t>
             </a:fld>
             <a:endParaRPr lang="de-DE"/>
           </a:p>
@@ -4107,7 +4192,7 @@
           <a:p>
             <a:fld id="{3146589B-F63A-42CD-B487-02649808258F}" type="datetimeFigureOut">
               <a:rPr lang="de-DE" smtClean="0"/>
-              <a:t>25.08.2025</a:t>
+              <a:t>28.08.2025</a:t>
             </a:fld>
             <a:endParaRPr lang="de-DE"/>
           </a:p>
@@ -4383,7 +4468,7 @@
           <a:p>
             <a:fld id="{3146589B-F63A-42CD-B487-02649808258F}" type="datetimeFigureOut">
               <a:rPr lang="de-DE" smtClean="0"/>
-              <a:t>25.08.2025</a:t>
+              <a:t>28.08.2025</a:t>
             </a:fld>
             <a:endParaRPr lang="de-DE"/>
           </a:p>
@@ -4651,7 +4736,7 @@
           <a:p>
             <a:fld id="{3146589B-F63A-42CD-B487-02649808258F}" type="datetimeFigureOut">
               <a:rPr lang="de-DE" smtClean="0"/>
-              <a:t>25.08.2025</a:t>
+              <a:t>28.08.2025</a:t>
             </a:fld>
             <a:endParaRPr lang="de-DE"/>
           </a:p>
@@ -5066,7 +5151,7 @@
           <a:p>
             <a:fld id="{3146589B-F63A-42CD-B487-02649808258F}" type="datetimeFigureOut">
               <a:rPr lang="de-DE" smtClean="0"/>
-              <a:t>25.08.2025</a:t>
+              <a:t>28.08.2025</a:t>
             </a:fld>
             <a:endParaRPr lang="de-DE"/>
           </a:p>
@@ -5208,7 +5293,7 @@
           <a:p>
             <a:fld id="{3146589B-F63A-42CD-B487-02649808258F}" type="datetimeFigureOut">
               <a:rPr lang="de-DE" smtClean="0"/>
-              <a:t>25.08.2025</a:t>
+              <a:t>28.08.2025</a:t>
             </a:fld>
             <a:endParaRPr lang="de-DE"/>
           </a:p>
@@ -5321,7 +5406,7 @@
           <a:p>
             <a:fld id="{3146589B-F63A-42CD-B487-02649808258F}" type="datetimeFigureOut">
               <a:rPr lang="de-DE" smtClean="0"/>
-              <a:t>25.08.2025</a:t>
+              <a:t>28.08.2025</a:t>
             </a:fld>
             <a:endParaRPr lang="de-DE"/>
           </a:p>
@@ -5634,7 +5719,7 @@
           <a:p>
             <a:fld id="{3146589B-F63A-42CD-B487-02649808258F}" type="datetimeFigureOut">
               <a:rPr lang="de-DE" smtClean="0"/>
-              <a:t>25.08.2025</a:t>
+              <a:t>28.08.2025</a:t>
             </a:fld>
             <a:endParaRPr lang="de-DE"/>
           </a:p>
@@ -5923,7 +6008,7 @@
           <a:p>
             <a:fld id="{3146589B-F63A-42CD-B487-02649808258F}" type="datetimeFigureOut">
               <a:rPr lang="de-DE" smtClean="0"/>
-              <a:t>25.08.2025</a:t>
+              <a:t>28.08.2025</a:t>
             </a:fld>
             <a:endParaRPr lang="de-DE"/>
           </a:p>
@@ -6166,7 +6251,7 @@
           <a:p>
             <a:fld id="{3146589B-F63A-42CD-B487-02649808258F}" type="datetimeFigureOut">
               <a:rPr lang="de-DE" smtClean="0"/>
-              <a:t>25.08.2025</a:t>
+              <a:t>28.08.2025</a:t>
             </a:fld>
             <a:endParaRPr lang="de-DE"/>
           </a:p>
@@ -8485,6 +8570,420 @@
       </p:grpSpPr>
       <p:pic>
         <p:nvPicPr>
+          <p:cNvPr id="10" name="Picture 9" descr="A pixelated image of a black and white square&#10;&#10;AI-generated content may be incorrect.">
+            <a:extLst>
+              <a:ext uri="{FF2B5EF4-FFF2-40B4-BE49-F238E27FC236}">
+                <a16:creationId xmlns:a16="http://schemas.microsoft.com/office/drawing/2014/main" id="{B00E4B1B-AE6F-5FDD-28BE-D8CB9C4A2F2D}"/>
+              </a:ext>
+            </a:extLst>
+          </p:cNvPr>
+          <p:cNvPicPr>
+            <a:picLocks noChangeAspect="1"/>
+          </p:cNvPicPr>
+          <p:nvPr/>
+        </p:nvPicPr>
+        <p:blipFill>
+          <a:blip r:embed="rId2">
+            <a:extLst>
+              <a:ext uri="{28A0092B-C50C-407E-A947-70E740481C1C}">
+                <a14:useLocalDpi xmlns:a14="http://schemas.microsoft.com/office/drawing/2010/main" val="0"/>
+              </a:ext>
+            </a:extLst>
+          </a:blip>
+          <a:stretch>
+            <a:fillRect/>
+          </a:stretch>
+        </p:blipFill>
+        <p:spPr>
+          <a:xfrm>
+            <a:off x="708053" y="218154"/>
+            <a:ext cx="3236983" cy="3236983"/>
+          </a:xfrm>
+          <a:prstGeom prst="rect">
+            <a:avLst/>
+          </a:prstGeom>
+        </p:spPr>
+      </p:pic>
+      <p:pic>
+        <p:nvPicPr>
+          <p:cNvPr id="13" name="Picture 12" descr="A black and white pixelated square&#10;&#10;AI-generated content may be incorrect.">
+            <a:extLst>
+              <a:ext uri="{FF2B5EF4-FFF2-40B4-BE49-F238E27FC236}">
+                <a16:creationId xmlns:a16="http://schemas.microsoft.com/office/drawing/2014/main" id="{0D9ADA81-E905-3774-D2CB-634192A29A61}"/>
+              </a:ext>
+            </a:extLst>
+          </p:cNvPr>
+          <p:cNvPicPr>
+            <a:picLocks noChangeAspect="1"/>
+          </p:cNvPicPr>
+          <p:nvPr/>
+        </p:nvPicPr>
+        <p:blipFill>
+          <a:blip r:embed="rId3">
+            <a:extLst>
+              <a:ext uri="{28A0092B-C50C-407E-A947-70E740481C1C}">
+                <a14:useLocalDpi xmlns:a14="http://schemas.microsoft.com/office/drawing/2010/main" val="0"/>
+              </a:ext>
+            </a:extLst>
+          </a:blip>
+          <a:stretch>
+            <a:fillRect/>
+          </a:stretch>
+        </p:blipFill>
+        <p:spPr>
+          <a:xfrm>
+            <a:off x="4164522" y="218154"/>
+            <a:ext cx="3236983" cy="3236983"/>
+          </a:xfrm>
+          <a:prstGeom prst="rect">
+            <a:avLst/>
+          </a:prstGeom>
+        </p:spPr>
+      </p:pic>
+      <p:pic>
+        <p:nvPicPr>
+          <p:cNvPr id="16" name="Picture 15" descr="A pixelated image of a black and white square&#10;&#10;AI-generated content may be incorrect.">
+            <a:extLst>
+              <a:ext uri="{FF2B5EF4-FFF2-40B4-BE49-F238E27FC236}">
+                <a16:creationId xmlns:a16="http://schemas.microsoft.com/office/drawing/2014/main" id="{3B6F989A-506C-5077-5884-4F94D607A125}"/>
+              </a:ext>
+            </a:extLst>
+          </p:cNvPr>
+          <p:cNvPicPr>
+            <a:picLocks noChangeAspect="1"/>
+          </p:cNvPicPr>
+          <p:nvPr/>
+        </p:nvPicPr>
+        <p:blipFill>
+          <a:blip r:embed="rId4">
+            <a:extLst>
+              <a:ext uri="{28A0092B-C50C-407E-A947-70E740481C1C}">
+                <a14:useLocalDpi xmlns:a14="http://schemas.microsoft.com/office/drawing/2010/main" val="0"/>
+              </a:ext>
+            </a:extLst>
+          </a:blip>
+          <a:stretch>
+            <a:fillRect/>
+          </a:stretch>
+        </p:blipFill>
+        <p:spPr>
+          <a:xfrm>
+            <a:off x="7620991" y="218154"/>
+            <a:ext cx="3236983" cy="3236983"/>
+          </a:xfrm>
+          <a:prstGeom prst="rect">
+            <a:avLst/>
+          </a:prstGeom>
+        </p:spPr>
+      </p:pic>
+      <p:pic>
+        <p:nvPicPr>
+          <p:cNvPr id="19" name="Picture 18" descr="A pixelated image of a black and white square&#10;&#10;AI-generated content may be incorrect.">
+            <a:extLst>
+              <a:ext uri="{FF2B5EF4-FFF2-40B4-BE49-F238E27FC236}">
+                <a16:creationId xmlns:a16="http://schemas.microsoft.com/office/drawing/2014/main" id="{1EBEE43C-540D-D316-5FA5-A944A41C619B}"/>
+              </a:ext>
+            </a:extLst>
+          </p:cNvPr>
+          <p:cNvPicPr>
+            <a:picLocks noChangeAspect="1"/>
+          </p:cNvPicPr>
+          <p:nvPr/>
+        </p:nvPicPr>
+        <p:blipFill>
+          <a:blip r:embed="rId5">
+            <a:extLst>
+              <a:ext uri="{28A0092B-C50C-407E-A947-70E740481C1C}">
+                <a14:useLocalDpi xmlns:a14="http://schemas.microsoft.com/office/drawing/2010/main" val="0"/>
+              </a:ext>
+            </a:extLst>
+          </a:blip>
+          <a:stretch>
+            <a:fillRect/>
+          </a:stretch>
+        </p:blipFill>
+        <p:spPr>
+          <a:xfrm>
+            <a:off x="708053" y="3557884"/>
+            <a:ext cx="3236983" cy="3236983"/>
+          </a:xfrm>
+          <a:prstGeom prst="rect">
+            <a:avLst/>
+          </a:prstGeom>
+        </p:spPr>
+      </p:pic>
+      <p:pic>
+        <p:nvPicPr>
+          <p:cNvPr id="21" name="Picture 20" descr="A black and white pixelated square&#10;&#10;AI-generated content may be incorrect.">
+            <a:extLst>
+              <a:ext uri="{FF2B5EF4-FFF2-40B4-BE49-F238E27FC236}">
+                <a16:creationId xmlns:a16="http://schemas.microsoft.com/office/drawing/2014/main" id="{D4D3CA93-3979-3975-8734-1FC1A4FF1BEA}"/>
+              </a:ext>
+            </a:extLst>
+          </p:cNvPr>
+          <p:cNvPicPr>
+            <a:picLocks noChangeAspect="1"/>
+          </p:cNvPicPr>
+          <p:nvPr/>
+        </p:nvPicPr>
+        <p:blipFill>
+          <a:blip r:embed="rId6">
+            <a:extLst>
+              <a:ext uri="{28A0092B-C50C-407E-A947-70E740481C1C}">
+                <a14:useLocalDpi xmlns:a14="http://schemas.microsoft.com/office/drawing/2010/main" val="0"/>
+              </a:ext>
+            </a:extLst>
+          </a:blip>
+          <a:stretch>
+            <a:fillRect/>
+          </a:stretch>
+        </p:blipFill>
+        <p:spPr>
+          <a:xfrm>
+            <a:off x="4164522" y="3557884"/>
+            <a:ext cx="3236983" cy="3236983"/>
+          </a:xfrm>
+          <a:prstGeom prst="rect">
+            <a:avLst/>
+          </a:prstGeom>
+        </p:spPr>
+      </p:pic>
+      <p:pic>
+        <p:nvPicPr>
+          <p:cNvPr id="27" name="Picture 26" descr="A pixelated image of a black and white square&#10;&#10;AI-generated content may be incorrect.">
+            <a:extLst>
+              <a:ext uri="{FF2B5EF4-FFF2-40B4-BE49-F238E27FC236}">
+                <a16:creationId xmlns:a16="http://schemas.microsoft.com/office/drawing/2014/main" id="{3B148123-512C-4CE9-AB62-6D6BE6ECD6F0}"/>
+              </a:ext>
+            </a:extLst>
+          </p:cNvPr>
+          <p:cNvPicPr>
+            <a:picLocks noChangeAspect="1"/>
+          </p:cNvPicPr>
+          <p:nvPr/>
+        </p:nvPicPr>
+        <p:blipFill>
+          <a:blip r:embed="rId7">
+            <a:extLst>
+              <a:ext uri="{28A0092B-C50C-407E-A947-70E740481C1C}">
+                <a14:useLocalDpi xmlns:a14="http://schemas.microsoft.com/office/drawing/2010/main" val="0"/>
+              </a:ext>
+            </a:extLst>
+          </a:blip>
+          <a:stretch>
+            <a:fillRect/>
+          </a:stretch>
+        </p:blipFill>
+        <p:spPr>
+          <a:xfrm>
+            <a:off x="7620991" y="3557884"/>
+            <a:ext cx="3236983" cy="3236983"/>
+          </a:xfrm>
+          <a:prstGeom prst="rect">
+            <a:avLst/>
+          </a:prstGeom>
+        </p:spPr>
+      </p:pic>
+      <p:cxnSp>
+        <p:nvCxnSpPr>
+          <p:cNvPr id="22" name="Straight Connector 21">
+            <a:extLst>
+              <a:ext uri="{FF2B5EF4-FFF2-40B4-BE49-F238E27FC236}">
+                <a16:creationId xmlns:a16="http://schemas.microsoft.com/office/drawing/2014/main" id="{A6298A49-1BB8-B363-5568-E3DD75F7D688}"/>
+              </a:ext>
+            </a:extLst>
+          </p:cNvPr>
+          <p:cNvCxnSpPr/>
+          <p:nvPr/>
+        </p:nvCxnSpPr>
+        <p:spPr>
+          <a:xfrm>
+            <a:off x="7867853" y="3484520"/>
+            <a:ext cx="3198657" cy="2971800"/>
+          </a:xfrm>
+          <a:prstGeom prst="line">
+            <a:avLst/>
+          </a:prstGeom>
+          <a:ln w="76200">
+            <a:solidFill>
+              <a:srgbClr val="FF0000"/>
+            </a:solidFill>
+          </a:ln>
+        </p:spPr>
+        <p:style>
+          <a:lnRef idx="2">
+            <a:schemeClr val="accent1"/>
+          </a:lnRef>
+          <a:fillRef idx="0">
+            <a:schemeClr val="accent1"/>
+          </a:fillRef>
+          <a:effectRef idx="1">
+            <a:schemeClr val="accent1"/>
+          </a:effectRef>
+          <a:fontRef idx="minor">
+            <a:schemeClr val="tx1"/>
+          </a:fontRef>
+        </p:style>
+      </p:cxnSp>
+      <p:cxnSp>
+        <p:nvCxnSpPr>
+          <p:cNvPr id="23" name="Straight Connector 22">
+            <a:extLst>
+              <a:ext uri="{FF2B5EF4-FFF2-40B4-BE49-F238E27FC236}">
+                <a16:creationId xmlns:a16="http://schemas.microsoft.com/office/drawing/2014/main" id="{6423B773-293E-5CF2-720C-FBB70CF0E5F1}"/>
+              </a:ext>
+            </a:extLst>
+          </p:cNvPr>
+          <p:cNvCxnSpPr>
+            <a:cxnSpLocks/>
+          </p:cNvCxnSpPr>
+          <p:nvPr/>
+        </p:nvCxnSpPr>
+        <p:spPr>
+          <a:xfrm rot="16200000">
+            <a:off x="7867853" y="3484520"/>
+            <a:ext cx="3198657" cy="2971800"/>
+          </a:xfrm>
+          <a:prstGeom prst="line">
+            <a:avLst/>
+          </a:prstGeom>
+          <a:ln w="76200">
+            <a:solidFill>
+              <a:srgbClr val="FF0000"/>
+            </a:solidFill>
+          </a:ln>
+        </p:spPr>
+        <p:style>
+          <a:lnRef idx="2">
+            <a:schemeClr val="accent1"/>
+          </a:lnRef>
+          <a:fillRef idx="0">
+            <a:schemeClr val="accent1"/>
+          </a:fillRef>
+          <a:effectRef idx="1">
+            <a:schemeClr val="accent1"/>
+          </a:effectRef>
+          <a:fontRef idx="minor">
+            <a:schemeClr val="tx1"/>
+          </a:fontRef>
+        </p:style>
+      </p:cxnSp>
+      <p:cxnSp>
+        <p:nvCxnSpPr>
+          <p:cNvPr id="25" name="Straight Connector 24">
+            <a:extLst>
+              <a:ext uri="{FF2B5EF4-FFF2-40B4-BE49-F238E27FC236}">
+                <a16:creationId xmlns:a16="http://schemas.microsoft.com/office/drawing/2014/main" id="{51EA2EBE-D20B-513E-1CAA-42EBA9E82B01}"/>
+              </a:ext>
+            </a:extLst>
+          </p:cNvPr>
+          <p:cNvCxnSpPr/>
+          <p:nvPr/>
+        </p:nvCxnSpPr>
+        <p:spPr>
+          <a:xfrm>
+            <a:off x="4485605" y="3542429"/>
+            <a:ext cx="3198657" cy="2971800"/>
+          </a:xfrm>
+          <a:prstGeom prst="line">
+            <a:avLst/>
+          </a:prstGeom>
+          <a:ln w="76200">
+            <a:solidFill>
+              <a:srgbClr val="FF0000"/>
+            </a:solidFill>
+          </a:ln>
+        </p:spPr>
+        <p:style>
+          <a:lnRef idx="2">
+            <a:schemeClr val="accent1"/>
+          </a:lnRef>
+          <a:fillRef idx="0">
+            <a:schemeClr val="accent1"/>
+          </a:fillRef>
+          <a:effectRef idx="1">
+            <a:schemeClr val="accent1"/>
+          </a:effectRef>
+          <a:fontRef idx="minor">
+            <a:schemeClr val="tx1"/>
+          </a:fontRef>
+        </p:style>
+      </p:cxnSp>
+      <p:cxnSp>
+        <p:nvCxnSpPr>
+          <p:cNvPr id="26" name="Straight Connector 25">
+            <a:extLst>
+              <a:ext uri="{FF2B5EF4-FFF2-40B4-BE49-F238E27FC236}">
+                <a16:creationId xmlns:a16="http://schemas.microsoft.com/office/drawing/2014/main" id="{199B7127-BAFE-9900-00F5-A3FFC7259493}"/>
+              </a:ext>
+            </a:extLst>
+          </p:cNvPr>
+          <p:cNvCxnSpPr>
+            <a:cxnSpLocks/>
+          </p:cNvCxnSpPr>
+          <p:nvPr/>
+        </p:nvCxnSpPr>
+        <p:spPr>
+          <a:xfrm rot="16200000">
+            <a:off x="4485605" y="3542429"/>
+            <a:ext cx="3198657" cy="2971800"/>
+          </a:xfrm>
+          <a:prstGeom prst="line">
+            <a:avLst/>
+          </a:prstGeom>
+          <a:ln w="76200">
+            <a:solidFill>
+              <a:srgbClr val="FF0000"/>
+            </a:solidFill>
+          </a:ln>
+        </p:spPr>
+        <p:style>
+          <a:lnRef idx="2">
+            <a:schemeClr val="accent1"/>
+          </a:lnRef>
+          <a:fillRef idx="0">
+            <a:schemeClr val="accent1"/>
+          </a:fillRef>
+          <a:effectRef idx="1">
+            <a:schemeClr val="accent1"/>
+          </a:effectRef>
+          <a:fontRef idx="minor">
+            <a:schemeClr val="tx1"/>
+          </a:fontRef>
+        </p:style>
+      </p:cxnSp>
+    </p:spTree>
+    <p:extLst>
+      <p:ext uri="{BB962C8B-B14F-4D97-AF65-F5344CB8AC3E}">
+        <p14:creationId xmlns:p14="http://schemas.microsoft.com/office/powerpoint/2010/main" val="3134903272"/>
+      </p:ext>
+    </p:extLst>
+  </p:cSld>
+  <p:clrMapOvr>
+    <a:masterClrMapping/>
+  </p:clrMapOvr>
+</p:sld>
+</file>
+
+<file path=ppt/slides/slide11.xml><?xml version="1.0" encoding="utf-8"?>
+<p:sld xmlns:a="http://schemas.openxmlformats.org/drawingml/2006/main" xmlns:r="http://schemas.openxmlformats.org/officeDocument/2006/relationships" xmlns:p="http://schemas.openxmlformats.org/presentationml/2006/main">
+  <p:cSld>
+    <p:spTree>
+      <p:nvGrpSpPr>
+        <p:cNvPr id="1" name=""/>
+        <p:cNvGrpSpPr/>
+        <p:nvPr/>
+      </p:nvGrpSpPr>
+      <p:grpSpPr>
+        <a:xfrm>
+          <a:off x="0" y="0"/>
+          <a:ext cx="0" cy="0"/>
+          <a:chOff x="0" y="0"/>
+          <a:chExt cx="0" cy="0"/>
+        </a:xfrm>
+      </p:grpSpPr>
+      <p:pic>
+        <p:nvPicPr>
           <p:cNvPr id="29" name="Picture 28" descr="A black and white square with white squares&#10;&#10;AI-generated content may be incorrect.">
             <a:extLst>
               <a:ext uri="{FF2B5EF4-FFF2-40B4-BE49-F238E27FC236}">
@@ -8827,7 +9326,7 @@
 </p:sld>
 </file>
 
-<file path=ppt/slides/slide11.xml><?xml version="1.0" encoding="utf-8"?>
+<file path=ppt/slides/slide12.xml><?xml version="1.0" encoding="utf-8"?>
 <p:sld xmlns:a="http://schemas.openxmlformats.org/drawingml/2006/main" xmlns:r="http://schemas.openxmlformats.org/officeDocument/2006/relationships" xmlns:p="http://schemas.openxmlformats.org/presentationml/2006/main">
   <p:cSld>
     <p:spTree>
@@ -9406,7 +9905,7 @@
 </p:sld>
 </file>
 
-<file path=ppt/slides/slide12.xml><?xml version="1.0" encoding="utf-8"?>
+<file path=ppt/slides/slide13.xml><?xml version="1.0" encoding="utf-8"?>
 <p:sld xmlns:a="http://schemas.openxmlformats.org/drawingml/2006/main" xmlns:r="http://schemas.openxmlformats.org/officeDocument/2006/relationships" xmlns:p="http://schemas.openxmlformats.org/presentationml/2006/main">
   <p:cSld>
     <p:spTree>
@@ -9545,7 +10044,7 @@
 </p:sld>
 </file>
 
-<file path=ppt/slides/slide13.xml><?xml version="1.0" encoding="utf-8"?>
+<file path=ppt/slides/slide14.xml><?xml version="1.0" encoding="utf-8"?>
 <p:sld xmlns:a="http://schemas.openxmlformats.org/drawingml/2006/main" xmlns:r="http://schemas.openxmlformats.org/officeDocument/2006/relationships" xmlns:p="http://schemas.openxmlformats.org/presentationml/2006/main">
   <p:cSld>
     <p:spTree>
@@ -9992,7 +10491,7 @@
 </p:sld>
 </file>
 
-<file path=ppt/slides/slide14.xml><?xml version="1.0" encoding="utf-8"?>
+<file path=ppt/slides/slide15.xml><?xml version="1.0" encoding="utf-8"?>
 <p:sld xmlns:a="http://schemas.openxmlformats.org/drawingml/2006/main" xmlns:r="http://schemas.openxmlformats.org/officeDocument/2006/relationships" xmlns:p="http://schemas.openxmlformats.org/presentationml/2006/main">
   <p:cSld>
     <p:spTree>
@@ -10096,7 +10595,7 @@
 </p:sld>
 </file>
 
-<file path=ppt/slides/slide15.xml><?xml version="1.0" encoding="utf-8"?>
+<file path=ppt/slides/slide16.xml><?xml version="1.0" encoding="utf-8"?>
 <p:sld xmlns:a="http://schemas.openxmlformats.org/drawingml/2006/main" xmlns:r="http://schemas.openxmlformats.org/officeDocument/2006/relationships" xmlns:p="http://schemas.openxmlformats.org/presentationml/2006/main">
   <p:cSld>
     <p:spTree>
@@ -10408,7 +10907,7 @@
 </p:sld>
 </file>
 
-<file path=ppt/slides/slide16.xml><?xml version="1.0" encoding="utf-8"?>
+<file path=ppt/slides/slide17.xml><?xml version="1.0" encoding="utf-8"?>
 <p:sld xmlns:a="http://schemas.openxmlformats.org/drawingml/2006/main" xmlns:r="http://schemas.openxmlformats.org/officeDocument/2006/relationships" xmlns:p="http://schemas.openxmlformats.org/presentationml/2006/main">
   <p:cSld>
     <p:spTree>
@@ -10930,7 +11429,7 @@
 </p:sld>
 </file>
 
-<file path=ppt/slides/slide17.xml><?xml version="1.0" encoding="utf-8"?>
+<file path=ppt/slides/slide18.xml><?xml version="1.0" encoding="utf-8"?>
 <p:sld xmlns:a="http://schemas.openxmlformats.org/drawingml/2006/main" xmlns:r="http://schemas.openxmlformats.org/officeDocument/2006/relationships" xmlns:p="http://schemas.openxmlformats.org/presentationml/2006/main">
   <p:cSld>
     <p:spTree>
@@ -11244,7 +11743,7 @@
 </p:sld>
 </file>
 
-<file path=ppt/slides/slide18.xml><?xml version="1.0" encoding="utf-8"?>
+<file path=ppt/slides/slide19.xml><?xml version="1.0" encoding="utf-8"?>
 <p:sld xmlns:a="http://schemas.openxmlformats.org/drawingml/2006/main" xmlns:r="http://schemas.openxmlformats.org/officeDocument/2006/relationships" xmlns:p="http://schemas.openxmlformats.org/presentationml/2006/main">
   <p:cSld>
     <p:spTree>
@@ -11304,219 +11803,6 @@
           <a:p>
             <a:pPr algn="ctr"/>
             <a:endParaRPr lang="de-DE"/>
-          </a:p>
-        </p:txBody>
-      </p:sp>
-      <p:sp>
-        <p:nvSpPr>
-          <p:cNvPr id="20" name="TextBox 19">
-            <a:extLst>
-              <a:ext uri="{FF2B5EF4-FFF2-40B4-BE49-F238E27FC236}">
-                <a16:creationId xmlns:a16="http://schemas.microsoft.com/office/drawing/2014/main" id="{526443CF-95C1-C731-FAFE-D8041279C723}"/>
-              </a:ext>
-            </a:extLst>
-          </p:cNvPr>
-          <p:cNvSpPr txBox="1"/>
-          <p:nvPr/>
-        </p:nvSpPr>
-        <p:spPr>
-          <a:xfrm>
-            <a:off x="2061450" y="5146236"/>
-            <a:ext cx="830677" cy="461665"/>
-          </a:xfrm>
-          <a:prstGeom prst="rect">
-            <a:avLst/>
-          </a:prstGeom>
-          <a:noFill/>
-        </p:spPr>
-        <p:txBody>
-          <a:bodyPr wrap="none" rtlCol="0">
-            <a:spAutoFit/>
-          </a:bodyPr>
-          <a:lstStyle/>
-          <a:p>
-            <a:r>
-              <a:rPr lang="de-DE" sz="2400" dirty="0"/>
-              <a:t>Time</a:t>
-            </a:r>
-          </a:p>
-        </p:txBody>
-      </p:sp>
-      <p:cxnSp>
-        <p:nvCxnSpPr>
-          <p:cNvPr id="21" name="Straight Arrow Connector 20">
-            <a:extLst>
-              <a:ext uri="{FF2B5EF4-FFF2-40B4-BE49-F238E27FC236}">
-                <a16:creationId xmlns:a16="http://schemas.microsoft.com/office/drawing/2014/main" id="{591D1781-47F4-B402-FF44-430F64F2921C}"/>
-              </a:ext>
-            </a:extLst>
-          </p:cNvPr>
-          <p:cNvCxnSpPr>
-            <a:cxnSpLocks/>
-          </p:cNvCxnSpPr>
-          <p:nvPr/>
-        </p:nvCxnSpPr>
-        <p:spPr>
-          <a:xfrm flipV="1">
-            <a:off x="821860" y="1999482"/>
-            <a:ext cx="0" cy="2877318"/>
-          </a:xfrm>
-          <a:prstGeom prst="straightConnector1">
-            <a:avLst/>
-          </a:prstGeom>
-          <a:ln w="57150">
-            <a:tailEnd type="triangle"/>
-          </a:ln>
-        </p:spPr>
-        <p:style>
-          <a:lnRef idx="2">
-            <a:schemeClr val="accent1"/>
-          </a:lnRef>
-          <a:fillRef idx="0">
-            <a:schemeClr val="accent1"/>
-          </a:fillRef>
-          <a:effectRef idx="1">
-            <a:schemeClr val="accent1"/>
-          </a:effectRef>
-          <a:fontRef idx="minor">
-            <a:schemeClr val="tx1"/>
-          </a:fontRef>
-        </p:style>
-      </p:cxnSp>
-      <mc:AlternateContent xmlns:mc="http://schemas.openxmlformats.org/markup-compatibility/2006" xmlns:a14="http://schemas.microsoft.com/office/drawing/2010/main">
-        <mc:Choice Requires="a14">
-          <p:sp>
-            <p:nvSpPr>
-              <p:cNvPr id="23" name="TextBox 22">
-                <a:extLst>
-                  <a:ext uri="{FF2B5EF4-FFF2-40B4-BE49-F238E27FC236}">
-                    <a16:creationId xmlns:a16="http://schemas.microsoft.com/office/drawing/2014/main" id="{0253A647-BA26-440D-5BF4-D815CEED785B}"/>
-                  </a:ext>
-                </a:extLst>
-              </p:cNvPr>
-              <p:cNvSpPr txBox="1"/>
-              <p:nvPr/>
-            </p:nvSpPr>
-            <p:spPr>
-              <a:xfrm>
-                <a:off x="271786" y="3207308"/>
-                <a:ext cx="608885" cy="461665"/>
-              </a:xfrm>
-              <a:prstGeom prst="rect">
-                <a:avLst/>
-              </a:prstGeom>
-              <a:noFill/>
-            </p:spPr>
-            <p:txBody>
-              <a:bodyPr wrap="none" rtlCol="0">
-                <a:spAutoFit/>
-              </a:bodyPr>
-              <a:lstStyle/>
-              <a:p>
-                <a:pPr/>
-                <a14:m>
-                  <m:oMathPara xmlns:m="http://schemas.openxmlformats.org/officeDocument/2006/math">
-                    <m:oMathParaPr>
-                      <m:jc m:val="centerGroup"/>
-                    </m:oMathParaPr>
-                    <m:oMath xmlns:m="http://schemas.openxmlformats.org/officeDocument/2006/math">
-                      <m:r>
-                        <m:rPr>
-                          <m:sty m:val="p"/>
-                        </m:rPr>
-                        <a:rPr lang="de-DE" sz="2400" dirty="0" smtClean="0">
-                          <a:latin typeface="Cambria Math" panose="02040503050406030204" pitchFamily="18" charset="0"/>
-                        </a:rPr>
-                        <m:t>Δ</m:t>
-                      </m:r>
-                      <m:r>
-                        <a:rPr lang="de-DE" sz="2400" i="1" dirty="0">
-                          <a:latin typeface="Cambria Math" panose="02040503050406030204" pitchFamily="18" charset="0"/>
-                        </a:rPr>
-                        <m:t>𝑓</m:t>
-                      </m:r>
-                    </m:oMath>
-                  </m:oMathPara>
-                </a14:m>
-                <a:endParaRPr lang="de-DE" sz="2400" dirty="0"/>
-              </a:p>
-            </p:txBody>
-          </p:sp>
-        </mc:Choice>
-        <mc:Fallback xmlns="">
-          <p:sp>
-            <p:nvSpPr>
-              <p:cNvPr id="23" name="TextBox 22">
-                <a:extLst>
-                  <a:ext uri="{FF2B5EF4-FFF2-40B4-BE49-F238E27FC236}">
-                    <a16:creationId xmlns:a16="http://schemas.microsoft.com/office/drawing/2014/main" id="{0253A647-BA26-440D-5BF4-D815CEED785B}"/>
-                  </a:ext>
-                </a:extLst>
-              </p:cNvPr>
-              <p:cNvSpPr txBox="1">
-                <a:spLocks noRot="1" noChangeAspect="1" noMove="1" noResize="1" noEditPoints="1" noAdjustHandles="1" noChangeArrowheads="1" noChangeShapeType="1" noTextEdit="1"/>
-              </p:cNvSpPr>
-              <p:nvPr/>
-            </p:nvSpPr>
-            <p:spPr>
-              <a:xfrm>
-                <a:off x="271786" y="3207308"/>
-                <a:ext cx="608885" cy="461665"/>
-              </a:xfrm>
-              <a:prstGeom prst="rect">
-                <a:avLst/>
-              </a:prstGeom>
-              <a:blipFill>
-                <a:blip r:embed="rId6"/>
-                <a:stretch>
-                  <a:fillRect r="-2020" b="-15789"/>
-                </a:stretch>
-              </a:blipFill>
-            </p:spPr>
-            <p:txBody>
-              <a:bodyPr/>
-              <a:lstStyle/>
-              <a:p>
-                <a:r>
-                  <a:rPr lang="de-DE">
-                    <a:noFill/>
-                  </a:rPr>
-                  <a:t> </a:t>
-                </a:r>
-              </a:p>
-            </p:txBody>
-          </p:sp>
-        </mc:Fallback>
-      </mc:AlternateContent>
-      <p:sp>
-        <p:nvSpPr>
-          <p:cNvPr id="24" name="TextBox 23">
-            <a:extLst>
-              <a:ext uri="{FF2B5EF4-FFF2-40B4-BE49-F238E27FC236}">
-                <a16:creationId xmlns:a16="http://schemas.microsoft.com/office/drawing/2014/main" id="{4AFC3488-BB18-D932-BEF2-09CA48A6DBD0}"/>
-              </a:ext>
-            </a:extLst>
-          </p:cNvPr>
-          <p:cNvSpPr txBox="1"/>
-          <p:nvPr/>
-        </p:nvSpPr>
-        <p:spPr>
-          <a:xfrm>
-            <a:off x="4844143" y="740229"/>
-            <a:ext cx="184731" cy="369332"/>
-          </a:xfrm>
-          <a:prstGeom prst="rect">
-            <a:avLst/>
-          </a:prstGeom>
-          <a:noFill/>
-        </p:spPr>
-        <p:txBody>
-          <a:bodyPr wrap="none" rtlCol="0">
-            <a:spAutoFit/>
-          </a:bodyPr>
-          <a:lstStyle/>
-          <a:p>
-            <a:endParaRPr lang="de-DE" dirty="0"/>
           </a:p>
         </p:txBody>
       </p:sp>
@@ -11762,53 +12048,12 @@
           </a:p>
         </p:txBody>
       </p:sp>
-      <p:cxnSp>
-        <p:nvCxnSpPr>
-          <p:cNvPr id="32" name="Straight Arrow Connector 31">
-            <a:extLst>
-              <a:ext uri="{FF2B5EF4-FFF2-40B4-BE49-F238E27FC236}">
-                <a16:creationId xmlns:a16="http://schemas.microsoft.com/office/drawing/2014/main" id="{0C465B3F-711C-F0AB-690A-D8D51D938FBA}"/>
-              </a:ext>
-            </a:extLst>
-          </p:cNvPr>
-          <p:cNvCxnSpPr>
-            <a:cxnSpLocks/>
-          </p:cNvCxnSpPr>
-          <p:nvPr/>
-        </p:nvCxnSpPr>
-        <p:spPr>
-          <a:xfrm rot="5400000" flipV="1">
-            <a:off x="2470833" y="3641370"/>
-            <a:ext cx="0" cy="2877318"/>
-          </a:xfrm>
-          <a:prstGeom prst="straightConnector1">
-            <a:avLst/>
-          </a:prstGeom>
-          <a:ln w="57150">
-            <a:tailEnd type="triangle"/>
-          </a:ln>
-        </p:spPr>
-        <p:style>
-          <a:lnRef idx="2">
-            <a:schemeClr val="accent1"/>
-          </a:lnRef>
-          <a:fillRef idx="0">
-            <a:schemeClr val="accent1"/>
-          </a:fillRef>
-          <a:effectRef idx="1">
-            <a:schemeClr val="accent1"/>
-          </a:effectRef>
-          <a:fontRef idx="minor">
-            <a:schemeClr val="tx1"/>
-          </a:fontRef>
-        </p:style>
-      </p:cxnSp>
       <p:pic>
         <p:nvPicPr>
-          <p:cNvPr id="4" name="Picture 3" descr="A black and white pixelated background&#10;&#10;AI-generated content may be incorrect.">
-            <a:extLst>
-              <a:ext uri="{FF2B5EF4-FFF2-40B4-BE49-F238E27FC236}">
-                <a16:creationId xmlns:a16="http://schemas.microsoft.com/office/drawing/2014/main" id="{9F47E577-542F-E1B6-47A0-C130932DC7F9}"/>
+          <p:cNvPr id="8" name="Picture 7" descr="A grey and black squares&#10;&#10;AI-generated content may be incorrect.">
+            <a:extLst>
+              <a:ext uri="{FF2B5EF4-FFF2-40B4-BE49-F238E27FC236}">
+                <a16:creationId xmlns:a16="http://schemas.microsoft.com/office/drawing/2014/main" id="{D2DB9A23-5B83-4227-0484-3AA86D8F85EE}"/>
               </a:ext>
             </a:extLst>
           </p:cNvPr>
@@ -11818,43 +12063,7 @@
           <p:nvPr/>
         </p:nvPicPr>
         <p:blipFill>
-          <a:blip r:embed="rId7">
-            <a:extLst>
-              <a:ext uri="{28A0092B-C50C-407E-A947-70E740481C1C}">
-                <a14:useLocalDpi xmlns:a14="http://schemas.microsoft.com/office/drawing/2010/main" val="0"/>
-              </a:ext>
-            </a:extLst>
-          </a:blip>
-          <a:stretch>
-            <a:fillRect/>
-          </a:stretch>
-        </p:blipFill>
-        <p:spPr>
-          <a:xfrm>
-            <a:off x="972809" y="2071428"/>
-            <a:ext cx="2877318" cy="2877318"/>
-          </a:xfrm>
-          <a:prstGeom prst="rect">
-            <a:avLst/>
-          </a:prstGeom>
-        </p:spPr>
-      </p:pic>
-      <p:pic>
-        <p:nvPicPr>
-          <p:cNvPr id="8" name="Picture 7" descr="A grey and black squares&#10;&#10;AI-generated content may be incorrect.">
-            <a:extLst>
-              <a:ext uri="{FF2B5EF4-FFF2-40B4-BE49-F238E27FC236}">
-                <a16:creationId xmlns:a16="http://schemas.microsoft.com/office/drawing/2014/main" id="{D2DB9A23-5B83-4227-0484-3AA86D8F85EE}"/>
-              </a:ext>
-            </a:extLst>
-          </p:cNvPr>
-          <p:cNvPicPr>
-            <a:picLocks noChangeAspect="1"/>
-          </p:cNvPicPr>
-          <p:nvPr/>
-        </p:nvPicPr>
-        <p:blipFill>
-          <a:blip r:embed="rId8">
+          <a:blip r:embed="rId2">
             <a:extLst>
               <a:ext uri="{28A0092B-C50C-407E-A947-70E740481C1C}">
                 <a14:useLocalDpi xmlns:a14="http://schemas.microsoft.com/office/drawing/2010/main" val="0"/>
@@ -11890,7 +12099,7 @@
           <p:nvPr/>
         </p:nvPicPr>
         <p:blipFill>
-          <a:blip r:embed="rId9">
+          <a:blip r:embed="rId3">
             <a:extLst>
               <a:ext uri="{28A0092B-C50C-407E-A947-70E740481C1C}">
                 <a14:useLocalDpi xmlns:a14="http://schemas.microsoft.com/office/drawing/2010/main" val="0"/>
@@ -11913,10 +12122,10 @@
       </p:pic>
       <p:pic>
         <p:nvPicPr>
-          <p:cNvPr id="34" name="Picture 33" descr="A screenshot of a video game&#10;&#10;AI-generated content may be incorrect.">
-            <a:extLst>
-              <a:ext uri="{FF2B5EF4-FFF2-40B4-BE49-F238E27FC236}">
-                <a16:creationId xmlns:a16="http://schemas.microsoft.com/office/drawing/2014/main" id="{6DC6D991-A9F6-64B5-770A-CA9871CFB63B}"/>
+          <p:cNvPr id="42" name="Picture 41" descr="A screenshot of a cell phone&#10;&#10;AI-generated content may be incorrect.">
+            <a:extLst>
+              <a:ext uri="{FF2B5EF4-FFF2-40B4-BE49-F238E27FC236}">
+                <a16:creationId xmlns:a16="http://schemas.microsoft.com/office/drawing/2014/main" id="{A45DA63F-98B8-EA51-1A1C-846926C6AA85}"/>
               </a:ext>
             </a:extLst>
           </p:cNvPr>
@@ -11926,7 +12135,7 @@
           <p:nvPr/>
         </p:nvPicPr>
         <p:blipFill>
-          <a:blip r:embed="rId10">
+          <a:blip r:embed="rId4">
             <a:extLst>
               <a:ext uri="{28A0092B-C50C-407E-A947-70E740481C1C}">
                 <a14:useLocalDpi xmlns:a14="http://schemas.microsoft.com/office/drawing/2010/main" val="0"/>
@@ -11939,8 +12148,44 @@
         </p:blipFill>
         <p:spPr>
           <a:xfrm>
-            <a:off x="7890397" y="1999482"/>
-            <a:ext cx="3092967" cy="3434473"/>
+            <a:off x="7749574" y="2006353"/>
+            <a:ext cx="3087632" cy="3602238"/>
+          </a:xfrm>
+          <a:prstGeom prst="rect">
+            <a:avLst/>
+          </a:prstGeom>
+        </p:spPr>
+      </p:pic>
+      <p:pic>
+        <p:nvPicPr>
+          <p:cNvPr id="44" name="Picture 43" descr="A black and white pixelated image&#10;&#10;AI-generated content may be incorrect.">
+            <a:extLst>
+              <a:ext uri="{FF2B5EF4-FFF2-40B4-BE49-F238E27FC236}">
+                <a16:creationId xmlns:a16="http://schemas.microsoft.com/office/drawing/2014/main" id="{712C713E-47EE-627E-5851-C8F9868A458B}"/>
+              </a:ext>
+            </a:extLst>
+          </p:cNvPr>
+          <p:cNvPicPr>
+            <a:picLocks noChangeAspect="1"/>
+          </p:cNvPicPr>
+          <p:nvPr/>
+        </p:nvPicPr>
+        <p:blipFill>
+          <a:blip r:embed="rId5">
+            <a:extLst>
+              <a:ext uri="{28A0092B-C50C-407E-A947-70E740481C1C}">
+                <a14:useLocalDpi xmlns:a14="http://schemas.microsoft.com/office/drawing/2010/main" val="0"/>
+              </a:ext>
+            </a:extLst>
+          </a:blip>
+          <a:stretch>
+            <a:fillRect/>
+          </a:stretch>
+        </p:blipFill>
+        <p:spPr>
+          <a:xfrm>
+            <a:off x="276105" y="2012369"/>
+            <a:ext cx="3503117" cy="3503117"/>
           </a:xfrm>
           <a:prstGeom prst="rect">
             <a:avLst/>
@@ -11960,7 +12205,7 @@
 </p:sld>
 </file>
 
-<file path=ppt/slides/slide19.xml><?xml version="1.0" encoding="utf-8"?>
+<file path=ppt/slides/slide2.xml><?xml version="1.0" encoding="utf-8"?>
 <p:sld xmlns:a="http://schemas.openxmlformats.org/drawingml/2006/main" xmlns:r="http://schemas.openxmlformats.org/officeDocument/2006/relationships" xmlns:p="http://schemas.openxmlformats.org/presentationml/2006/main">
   <p:cSld>
     <p:spTree>
@@ -11979,10 +12224,10 @@
       </p:grpSpPr>
       <p:pic>
         <p:nvPicPr>
-          <p:cNvPr id="9" name="Picture 8" descr="A screenshot of a video game&#10;&#10;AI-generated content may be incorrect.">
-            <a:extLst>
-              <a:ext uri="{FF2B5EF4-FFF2-40B4-BE49-F238E27FC236}">
-                <a16:creationId xmlns:a16="http://schemas.microsoft.com/office/drawing/2014/main" id="{2EBCC2D2-F613-D665-403F-2B40B439025A}"/>
+          <p:cNvPr id="24" name="Picture 23" descr="A black background with a black square&#10;&#10;AI-generated content may be incorrect.">
+            <a:extLst>
+              <a:ext uri="{FF2B5EF4-FFF2-40B4-BE49-F238E27FC236}">
+                <a16:creationId xmlns:a16="http://schemas.microsoft.com/office/drawing/2014/main" id="{DF98AE41-A14D-5897-DDD2-193AD48FF39C}"/>
               </a:ext>
             </a:extLst>
           </p:cNvPr>
@@ -12005,8 +12250,613 @@
         </p:blipFill>
         <p:spPr>
           <a:xfrm>
-            <a:off x="5448639" y="1961107"/>
-            <a:ext cx="3076088" cy="3415731"/>
+            <a:off x="4039686" y="4738785"/>
+            <a:ext cx="4972386" cy="1656422"/>
+          </a:xfrm>
+          <a:prstGeom prst="rect">
+            <a:avLst/>
+          </a:prstGeom>
+        </p:spPr>
+      </p:pic>
+      <p:pic>
+        <p:nvPicPr>
+          <p:cNvPr id="5" name="Picture 4" descr="A blue line on a black background&#10;&#10;AI-generated content may be incorrect.">
+            <a:extLst>
+              <a:ext uri="{FF2B5EF4-FFF2-40B4-BE49-F238E27FC236}">
+                <a16:creationId xmlns:a16="http://schemas.microsoft.com/office/drawing/2014/main" id="{71469AEB-366D-4C33-1D3F-6193B1F0F974}"/>
+              </a:ext>
+            </a:extLst>
+          </p:cNvPr>
+          <p:cNvPicPr>
+            <a:picLocks noChangeAspect="1"/>
+          </p:cNvPicPr>
+          <p:nvPr/>
+        </p:nvPicPr>
+        <p:blipFill>
+          <a:blip r:embed="rId3">
+            <a:extLst>
+              <a:ext uri="{28A0092B-C50C-407E-A947-70E740481C1C}">
+                <a14:useLocalDpi xmlns:a14="http://schemas.microsoft.com/office/drawing/2010/main" val="0"/>
+              </a:ext>
+            </a:extLst>
+          </a:blip>
+          <a:stretch>
+            <a:fillRect/>
+          </a:stretch>
+        </p:blipFill>
+        <p:spPr>
+          <a:xfrm>
+            <a:off x="6935507" y="551263"/>
+            <a:ext cx="4858522" cy="1618491"/>
+          </a:xfrm>
+          <a:prstGeom prst="rect">
+            <a:avLst/>
+          </a:prstGeom>
+        </p:spPr>
+      </p:pic>
+      <p:pic>
+        <p:nvPicPr>
+          <p:cNvPr id="7" name="Picture 6" descr="A blue line on a black background&#10;&#10;AI-generated content may be incorrect.">
+            <a:extLst>
+              <a:ext uri="{FF2B5EF4-FFF2-40B4-BE49-F238E27FC236}">
+                <a16:creationId xmlns:a16="http://schemas.microsoft.com/office/drawing/2014/main" id="{764FB2D9-F81D-A172-254F-DFBB42F8FA85}"/>
+              </a:ext>
+            </a:extLst>
+          </p:cNvPr>
+          <p:cNvPicPr>
+            <a:picLocks noChangeAspect="1"/>
+          </p:cNvPicPr>
+          <p:nvPr/>
+        </p:nvPicPr>
+        <p:blipFill>
+          <a:blip r:embed="rId4">
+            <a:extLst>
+              <a:ext uri="{28A0092B-C50C-407E-A947-70E740481C1C}">
+                <a14:useLocalDpi xmlns:a14="http://schemas.microsoft.com/office/drawing/2010/main" val="0"/>
+              </a:ext>
+            </a:extLst>
+          </a:blip>
+          <a:stretch>
+            <a:fillRect/>
+          </a:stretch>
+        </p:blipFill>
+        <p:spPr>
+          <a:xfrm>
+            <a:off x="1237478" y="551263"/>
+            <a:ext cx="4858522" cy="1618491"/>
+          </a:xfrm>
+          <a:prstGeom prst="rect">
+            <a:avLst/>
+          </a:prstGeom>
+        </p:spPr>
+      </p:pic>
+      <p:pic>
+        <p:nvPicPr>
+          <p:cNvPr id="9" name="Picture 8" descr="A black background with a black square&#10;&#10;AI-generated content may be incorrect.">
+            <a:extLst>
+              <a:ext uri="{FF2B5EF4-FFF2-40B4-BE49-F238E27FC236}">
+                <a16:creationId xmlns:a16="http://schemas.microsoft.com/office/drawing/2014/main" id="{35866380-AF32-7A31-256D-3ABB5223CBF6}"/>
+              </a:ext>
+            </a:extLst>
+          </p:cNvPr>
+          <p:cNvPicPr>
+            <a:picLocks noChangeAspect="1"/>
+          </p:cNvPicPr>
+          <p:nvPr/>
+        </p:nvPicPr>
+        <p:blipFill>
+          <a:blip r:embed="rId5">
+            <a:extLst>
+              <a:ext uri="{28A0092B-C50C-407E-A947-70E740481C1C}">
+                <a14:useLocalDpi xmlns:a14="http://schemas.microsoft.com/office/drawing/2010/main" val="0"/>
+              </a:ext>
+            </a:extLst>
+          </a:blip>
+          <a:stretch>
+            <a:fillRect/>
+          </a:stretch>
+        </p:blipFill>
+        <p:spPr>
+          <a:xfrm>
+            <a:off x="1237478" y="2976600"/>
+            <a:ext cx="4858522" cy="1618491"/>
+          </a:xfrm>
+          <a:prstGeom prst="rect">
+            <a:avLst/>
+          </a:prstGeom>
+        </p:spPr>
+      </p:pic>
+      <p:pic>
+        <p:nvPicPr>
+          <p:cNvPr id="11" name="Picture 10" descr="A black background with a black square&#10;&#10;AI-generated content may be incorrect.">
+            <a:extLst>
+              <a:ext uri="{FF2B5EF4-FFF2-40B4-BE49-F238E27FC236}">
+                <a16:creationId xmlns:a16="http://schemas.microsoft.com/office/drawing/2014/main" id="{07785DB6-5B6E-432E-2389-A17613087EFF}"/>
+              </a:ext>
+            </a:extLst>
+          </p:cNvPr>
+          <p:cNvPicPr>
+            <a:picLocks noChangeAspect="1"/>
+          </p:cNvPicPr>
+          <p:nvPr/>
+        </p:nvPicPr>
+        <p:blipFill>
+          <a:blip r:embed="rId6">
+            <a:extLst>
+              <a:ext uri="{28A0092B-C50C-407E-A947-70E740481C1C}">
+                <a14:useLocalDpi xmlns:a14="http://schemas.microsoft.com/office/drawing/2010/main" val="0"/>
+              </a:ext>
+            </a:extLst>
+          </a:blip>
+          <a:stretch>
+            <a:fillRect/>
+          </a:stretch>
+        </p:blipFill>
+        <p:spPr>
+          <a:xfrm>
+            <a:off x="6935507" y="2976600"/>
+            <a:ext cx="4858522" cy="1618491"/>
+          </a:xfrm>
+          <a:prstGeom prst="rect">
+            <a:avLst/>
+          </a:prstGeom>
+        </p:spPr>
+      </p:pic>
+      <p:sp>
+        <p:nvSpPr>
+          <p:cNvPr id="14" name="Arrow: Down 13">
+            <a:extLst>
+              <a:ext uri="{FF2B5EF4-FFF2-40B4-BE49-F238E27FC236}">
+                <a16:creationId xmlns:a16="http://schemas.microsoft.com/office/drawing/2014/main" id="{58DF4E64-60CD-1188-F7F1-F26177CC64FD}"/>
+              </a:ext>
+            </a:extLst>
+          </p:cNvPr>
+          <p:cNvSpPr/>
+          <p:nvPr/>
+        </p:nvSpPr>
+        <p:spPr>
+          <a:xfrm>
+            <a:off x="3424423" y="2271420"/>
+            <a:ext cx="484632" cy="647057"/>
+          </a:xfrm>
+          <a:prstGeom prst="downArrow">
+            <a:avLst/>
+          </a:prstGeom>
+          <a:solidFill>
+            <a:schemeClr val="accent5">
+              <a:lumMod val="60000"/>
+              <a:lumOff val="40000"/>
+            </a:schemeClr>
+          </a:solidFill>
+          <a:ln w="28575">
+            <a:noFill/>
+          </a:ln>
+        </p:spPr>
+        <p:style>
+          <a:lnRef idx="2">
+            <a:schemeClr val="accent1">
+              <a:shade val="15000"/>
+            </a:schemeClr>
+          </a:lnRef>
+          <a:fillRef idx="1">
+            <a:schemeClr val="accent1"/>
+          </a:fillRef>
+          <a:effectRef idx="0">
+            <a:schemeClr val="accent1"/>
+          </a:effectRef>
+          <a:fontRef idx="minor">
+            <a:schemeClr val="lt1"/>
+          </a:fontRef>
+        </p:style>
+        <p:txBody>
+          <a:bodyPr rtlCol="0" anchor="ctr"/>
+          <a:lstStyle/>
+          <a:p>
+            <a:pPr algn="ctr"/>
+            <a:endParaRPr lang="de-DE"/>
+          </a:p>
+        </p:txBody>
+      </p:sp>
+      <p:sp>
+        <p:nvSpPr>
+          <p:cNvPr id="15" name="Arrow: Down 14">
+            <a:extLst>
+              <a:ext uri="{FF2B5EF4-FFF2-40B4-BE49-F238E27FC236}">
+                <a16:creationId xmlns:a16="http://schemas.microsoft.com/office/drawing/2014/main" id="{054FAF89-6E3B-2058-B4E4-CEBF9C8BEBED}"/>
+              </a:ext>
+            </a:extLst>
+          </p:cNvPr>
+          <p:cNvSpPr/>
+          <p:nvPr/>
+        </p:nvSpPr>
+        <p:spPr>
+          <a:xfrm>
+            <a:off x="9122452" y="2271420"/>
+            <a:ext cx="484632" cy="647057"/>
+          </a:xfrm>
+          <a:prstGeom prst="downArrow">
+            <a:avLst/>
+          </a:prstGeom>
+          <a:solidFill>
+            <a:schemeClr val="accent5">
+              <a:lumMod val="60000"/>
+              <a:lumOff val="40000"/>
+            </a:schemeClr>
+          </a:solidFill>
+          <a:ln w="28575">
+            <a:noFill/>
+          </a:ln>
+        </p:spPr>
+        <p:style>
+          <a:lnRef idx="2">
+            <a:schemeClr val="accent1">
+              <a:shade val="15000"/>
+            </a:schemeClr>
+          </a:lnRef>
+          <a:fillRef idx="1">
+            <a:schemeClr val="accent1"/>
+          </a:fillRef>
+          <a:effectRef idx="0">
+            <a:schemeClr val="accent1"/>
+          </a:effectRef>
+          <a:fontRef idx="minor">
+            <a:schemeClr val="lt1"/>
+          </a:fontRef>
+        </p:style>
+        <p:txBody>
+          <a:bodyPr rtlCol="0" anchor="ctr"/>
+          <a:lstStyle/>
+          <a:p>
+            <a:pPr algn="ctr"/>
+            <a:endParaRPr lang="de-DE"/>
+          </a:p>
+        </p:txBody>
+      </p:sp>
+      <mc:AlternateContent xmlns:mc="http://schemas.openxmlformats.org/markup-compatibility/2006">
+        <mc:Choice xmlns:a14="http://schemas.microsoft.com/office/drawing/2010/main" Requires="a14">
+          <p:sp>
+            <p:nvSpPr>
+              <p:cNvPr id="16" name="TextBox 15">
+                <a:extLst>
+                  <a:ext uri="{FF2B5EF4-FFF2-40B4-BE49-F238E27FC236}">
+                    <a16:creationId xmlns:a16="http://schemas.microsoft.com/office/drawing/2014/main" id="{5D74A2B0-4613-45BE-EC54-D5D8E8185135}"/>
+                  </a:ext>
+                </a:extLst>
+              </p:cNvPr>
+              <p:cNvSpPr txBox="1"/>
+              <p:nvPr/>
+            </p:nvSpPr>
+            <p:spPr>
+              <a:xfrm>
+                <a:off x="2802976" y="2280789"/>
+                <a:ext cx="863763" cy="584775"/>
+              </a:xfrm>
+              <a:prstGeom prst="rect">
+                <a:avLst/>
+              </a:prstGeom>
+              <a:noFill/>
+            </p:spPr>
+            <p:txBody>
+              <a:bodyPr wrap="none" rtlCol="0">
+                <a:spAutoFit/>
+              </a:bodyPr>
+              <a:lstStyle/>
+              <a:p>
+                <a14:m>
+                  <m:oMathPara xmlns:m="http://schemas.openxmlformats.org/officeDocument/2006/math">
+                    <m:oMathParaPr>
+                      <m:jc m:val="centerGroup"/>
+                    </m:oMathParaPr>
+                    <m:oMath xmlns:m="http://schemas.openxmlformats.org/officeDocument/2006/math">
+                      <m:sSup>
+                        <m:sSupPr>
+                          <m:ctrlPr>
+                            <a:rPr lang="de-DE" sz="3200" i="1" smtClean="0">
+                              <a:latin typeface="Cambria Math" panose="02040503050406030204" pitchFamily="18" charset="0"/>
+                            </a:rPr>
+                          </m:ctrlPr>
+                        </m:sSupPr>
+                        <m:e>
+                          <m:r>
+                            <m:rPr>
+                              <m:nor/>
+                            </m:rPr>
+                            <a:rPr lang="de-DE" sz="3200"/>
+                            <m:t>𝓕</m:t>
+                          </m:r>
+                        </m:e>
+                        <m:sup>
+                          <m:r>
+                            <a:rPr lang="de-DE" sz="3200" b="0" i="1" smtClean="0">
+                              <a:latin typeface="Cambria Math" panose="02040503050406030204" pitchFamily="18" charset="0"/>
+                            </a:rPr>
+                            <m:t>-1</m:t>
+                          </m:r>
+                        </m:sup>
+                      </m:sSup>
+                    </m:oMath>
+                  </m:oMathPara>
+                </a14:m>
+                <a:endParaRPr lang="de-DE" sz="3200" dirty="0"/>
+              </a:p>
+            </p:txBody>
+          </p:sp>
+        </mc:Choice>
+        <mc:Fallback>
+          <p:sp>
+            <p:nvSpPr>
+              <p:cNvPr id="16" name="TextBox 15">
+                <a:extLst>
+                  <a:ext uri="{FF2B5EF4-FFF2-40B4-BE49-F238E27FC236}">
+                    <a16:creationId xmlns:a16="http://schemas.microsoft.com/office/drawing/2014/main" id="{5D74A2B0-4613-45BE-EC54-D5D8E8185135}"/>
+                  </a:ext>
+                </a:extLst>
+              </p:cNvPr>
+              <p:cNvSpPr txBox="1">
+                <a:spLocks noRot="1" noChangeAspect="1" noMove="1" noResize="1" noEditPoints="1" noAdjustHandles="1" noChangeArrowheads="1" noChangeShapeType="1" noTextEdit="1"/>
+              </p:cNvSpPr>
+              <p:nvPr/>
+            </p:nvSpPr>
+            <p:spPr>
+              <a:xfrm>
+                <a:off x="2802976" y="2280789"/>
+                <a:ext cx="863763" cy="584775"/>
+              </a:xfrm>
+              <a:prstGeom prst="rect">
+                <a:avLst/>
+              </a:prstGeom>
+              <a:blipFill>
+                <a:blip r:embed="rId7"/>
+                <a:stretch>
+                  <a:fillRect/>
+                </a:stretch>
+              </a:blipFill>
+            </p:spPr>
+            <p:txBody>
+              <a:bodyPr/>
+              <a:lstStyle/>
+              <a:p>
+                <a:r>
+                  <a:rPr lang="de-DE">
+                    <a:noFill/>
+                  </a:rPr>
+                  <a:t> </a:t>
+                </a:r>
+              </a:p>
+            </p:txBody>
+          </p:sp>
+        </mc:Fallback>
+      </mc:AlternateContent>
+      <mc:AlternateContent xmlns:mc="http://schemas.openxmlformats.org/markup-compatibility/2006">
+        <mc:Choice xmlns:a14="http://schemas.microsoft.com/office/drawing/2010/main" Requires="a14">
+          <p:sp>
+            <p:nvSpPr>
+              <p:cNvPr id="17" name="TextBox 16">
+                <a:extLst>
+                  <a:ext uri="{FF2B5EF4-FFF2-40B4-BE49-F238E27FC236}">
+                    <a16:creationId xmlns:a16="http://schemas.microsoft.com/office/drawing/2014/main" id="{387533DA-0227-B5C0-B4B0-13137F4CD3F9}"/>
+                  </a:ext>
+                </a:extLst>
+              </p:cNvPr>
+              <p:cNvSpPr txBox="1"/>
+              <p:nvPr/>
+            </p:nvSpPr>
+            <p:spPr>
+              <a:xfrm>
+                <a:off x="8491798" y="2280789"/>
+                <a:ext cx="863763" cy="584775"/>
+              </a:xfrm>
+              <a:prstGeom prst="rect">
+                <a:avLst/>
+              </a:prstGeom>
+              <a:noFill/>
+            </p:spPr>
+            <p:txBody>
+              <a:bodyPr wrap="none" rtlCol="0">
+                <a:spAutoFit/>
+              </a:bodyPr>
+              <a:lstStyle/>
+              <a:p>
+                <a14:m>
+                  <m:oMathPara xmlns:m="http://schemas.openxmlformats.org/officeDocument/2006/math">
+                    <m:oMathParaPr>
+                      <m:jc m:val="centerGroup"/>
+                    </m:oMathParaPr>
+                    <m:oMath xmlns:m="http://schemas.openxmlformats.org/officeDocument/2006/math">
+                      <m:sSup>
+                        <m:sSupPr>
+                          <m:ctrlPr>
+                            <a:rPr lang="de-DE" sz="3200" i="1" smtClean="0">
+                              <a:latin typeface="Cambria Math" panose="02040503050406030204" pitchFamily="18" charset="0"/>
+                            </a:rPr>
+                          </m:ctrlPr>
+                        </m:sSupPr>
+                        <m:e>
+                          <m:r>
+                            <m:rPr>
+                              <m:nor/>
+                            </m:rPr>
+                            <a:rPr lang="de-DE" sz="3200"/>
+                            <m:t>𝓕</m:t>
+                          </m:r>
+                        </m:e>
+                        <m:sup>
+                          <m:r>
+                            <a:rPr lang="de-DE" sz="3200" b="0" i="1" smtClean="0">
+                              <a:latin typeface="Cambria Math" panose="02040503050406030204" pitchFamily="18" charset="0"/>
+                            </a:rPr>
+                            <m:t>-1</m:t>
+                          </m:r>
+                        </m:sup>
+                      </m:sSup>
+                    </m:oMath>
+                  </m:oMathPara>
+                </a14:m>
+                <a:endParaRPr lang="de-DE" sz="3200" dirty="0"/>
+              </a:p>
+            </p:txBody>
+          </p:sp>
+        </mc:Choice>
+        <mc:Fallback>
+          <p:sp>
+            <p:nvSpPr>
+              <p:cNvPr id="17" name="TextBox 16">
+                <a:extLst>
+                  <a:ext uri="{FF2B5EF4-FFF2-40B4-BE49-F238E27FC236}">
+                    <a16:creationId xmlns:a16="http://schemas.microsoft.com/office/drawing/2014/main" id="{387533DA-0227-B5C0-B4B0-13137F4CD3F9}"/>
+                  </a:ext>
+                </a:extLst>
+              </p:cNvPr>
+              <p:cNvSpPr txBox="1">
+                <a:spLocks noRot="1" noChangeAspect="1" noMove="1" noResize="1" noEditPoints="1" noAdjustHandles="1" noChangeArrowheads="1" noChangeShapeType="1" noTextEdit="1"/>
+              </p:cNvSpPr>
+              <p:nvPr/>
+            </p:nvSpPr>
+            <p:spPr>
+              <a:xfrm>
+                <a:off x="8491798" y="2280789"/>
+                <a:ext cx="863763" cy="584775"/>
+              </a:xfrm>
+              <a:prstGeom prst="rect">
+                <a:avLst/>
+              </a:prstGeom>
+              <a:blipFill>
+                <a:blip r:embed="rId8"/>
+                <a:stretch>
+                  <a:fillRect/>
+                </a:stretch>
+              </a:blipFill>
+            </p:spPr>
+            <p:txBody>
+              <a:bodyPr/>
+              <a:lstStyle/>
+              <a:p>
+                <a:r>
+                  <a:rPr lang="de-DE">
+                    <a:noFill/>
+                  </a:rPr>
+                  <a:t> </a:t>
+                </a:r>
+              </a:p>
+            </p:txBody>
+          </p:sp>
+        </mc:Fallback>
+      </mc:AlternateContent>
+      <p:sp>
+        <p:nvSpPr>
+          <p:cNvPr id="18" name="Right Brace 17">
+            <a:extLst>
+              <a:ext uri="{FF2B5EF4-FFF2-40B4-BE49-F238E27FC236}">
+                <a16:creationId xmlns:a16="http://schemas.microsoft.com/office/drawing/2014/main" id="{954462B1-6726-DF3B-57C1-D259AFA6FBB8}"/>
+              </a:ext>
+            </a:extLst>
+          </p:cNvPr>
+          <p:cNvSpPr/>
+          <p:nvPr/>
+        </p:nvSpPr>
+        <p:spPr>
+          <a:xfrm rot="5400000">
+            <a:off x="5986375" y="-683185"/>
+            <a:ext cx="1058758" cy="10556551"/>
+          </a:xfrm>
+          <a:prstGeom prst="rightBrace">
+            <a:avLst>
+              <a:gd name="adj1" fmla="val 48431"/>
+              <a:gd name="adj2" fmla="val 50000"/>
+            </a:avLst>
+          </a:prstGeom>
+          <a:ln w="57150">
+            <a:solidFill>
+              <a:schemeClr val="accent5">
+                <a:lumMod val="60000"/>
+                <a:lumOff val="40000"/>
+              </a:schemeClr>
+            </a:solidFill>
+          </a:ln>
+        </p:spPr>
+        <p:style>
+          <a:lnRef idx="2">
+            <a:schemeClr val="accent1"/>
+          </a:lnRef>
+          <a:fillRef idx="0">
+            <a:schemeClr val="accent1"/>
+          </a:fillRef>
+          <a:effectRef idx="1">
+            <a:schemeClr val="accent1"/>
+          </a:effectRef>
+          <a:fontRef idx="minor">
+            <a:schemeClr val="tx1"/>
+          </a:fontRef>
+        </p:style>
+        <p:txBody>
+          <a:bodyPr rtlCol="0" anchor="ctr"/>
+          <a:lstStyle/>
+          <a:p>
+            <a:pPr algn="ctr"/>
+            <a:endParaRPr lang="de-DE"/>
+          </a:p>
+        </p:txBody>
+      </p:sp>
+    </p:spTree>
+    <p:extLst>
+      <p:ext uri="{BB962C8B-B14F-4D97-AF65-F5344CB8AC3E}">
+        <p14:creationId xmlns:p14="http://schemas.microsoft.com/office/powerpoint/2010/main" val="2049215089"/>
+      </p:ext>
+    </p:extLst>
+  </p:cSld>
+  <p:clrMapOvr>
+    <a:masterClrMapping/>
+  </p:clrMapOvr>
+</p:sld>
+</file>
+
+<file path=ppt/slides/slide20.xml><?xml version="1.0" encoding="utf-8"?>
+<p:sld xmlns:a="http://schemas.openxmlformats.org/drawingml/2006/main" xmlns:r="http://schemas.openxmlformats.org/officeDocument/2006/relationships" xmlns:p="http://schemas.openxmlformats.org/presentationml/2006/main">
+  <p:cSld>
+    <p:spTree>
+      <p:nvGrpSpPr>
+        <p:cNvPr id="1" name=""/>
+        <p:cNvGrpSpPr/>
+        <p:nvPr/>
+      </p:nvGrpSpPr>
+      <p:grpSpPr>
+        <a:xfrm>
+          <a:off x="0" y="0"/>
+          <a:ext cx="0" cy="0"/>
+          <a:chOff x="0" y="0"/>
+          <a:chExt cx="0" cy="0"/>
+        </a:xfrm>
+      </p:grpSpPr>
+      <p:pic>
+        <p:nvPicPr>
+          <p:cNvPr id="45" name="Picture 44" descr="A screenshot of a computer&#10;&#10;AI-generated content may be incorrect.">
+            <a:extLst>
+              <a:ext uri="{FF2B5EF4-FFF2-40B4-BE49-F238E27FC236}">
+                <a16:creationId xmlns:a16="http://schemas.microsoft.com/office/drawing/2014/main" id="{F31CC08F-9A70-0EE5-EC5E-4498304F241E}"/>
+              </a:ext>
+            </a:extLst>
+          </p:cNvPr>
+          <p:cNvPicPr>
+            <a:picLocks noChangeAspect="1"/>
+          </p:cNvPicPr>
+          <p:nvPr/>
+        </p:nvPicPr>
+        <p:blipFill>
+          <a:blip r:embed="rId3">
+            <a:extLst>
+              <a:ext uri="{28A0092B-C50C-407E-A947-70E740481C1C}">
+                <a14:useLocalDpi xmlns:a14="http://schemas.microsoft.com/office/drawing/2010/main" val="0"/>
+              </a:ext>
+            </a:extLst>
+          </a:blip>
+          <a:stretch>
+            <a:fillRect/>
+          </a:stretch>
+        </p:blipFill>
+        <p:spPr>
+          <a:xfrm>
+            <a:off x="5247184" y="1999482"/>
+            <a:ext cx="3377355" cy="3377355"/>
           </a:xfrm>
           <a:prstGeom prst="rect">
             <a:avLst/>
@@ -12061,10 +12911,10 @@
       </p:sp>
       <p:sp>
         <p:nvSpPr>
-          <p:cNvPr id="11" name="TextBox 10">
-            <a:extLst>
-              <a:ext uri="{FF2B5EF4-FFF2-40B4-BE49-F238E27FC236}">
-                <a16:creationId xmlns:a16="http://schemas.microsoft.com/office/drawing/2014/main" id="{7176EDA6-BB3C-7306-4DB4-082812C2B491}"/>
+          <p:cNvPr id="15" name="TextBox 14">
+            <a:extLst>
+              <a:ext uri="{FF2B5EF4-FFF2-40B4-BE49-F238E27FC236}">
+                <a16:creationId xmlns:a16="http://schemas.microsoft.com/office/drawing/2014/main" id="{898BD7CD-F3D1-046B-9F2A-9F150D497AA7}"/>
               </a:ext>
             </a:extLst>
           </p:cNvPr>
@@ -12073,189 +12923,8 @@
         </p:nvSpPr>
         <p:spPr>
           <a:xfrm>
-            <a:off x="2061450" y="5146236"/>
-            <a:ext cx="830677" cy="461665"/>
-          </a:xfrm>
-          <a:prstGeom prst="rect">
-            <a:avLst/>
-          </a:prstGeom>
-          <a:noFill/>
-        </p:spPr>
-        <p:txBody>
-          <a:bodyPr wrap="none" rtlCol="0">
-            <a:spAutoFit/>
-          </a:bodyPr>
-          <a:lstStyle/>
-          <a:p>
-            <a:r>
-              <a:rPr lang="de-DE" sz="2400" dirty="0"/>
-              <a:t>Time</a:t>
-            </a:r>
-          </a:p>
-        </p:txBody>
-      </p:sp>
-      <p:cxnSp>
-        <p:nvCxnSpPr>
-          <p:cNvPr id="12" name="Straight Arrow Connector 11">
-            <a:extLst>
-              <a:ext uri="{FF2B5EF4-FFF2-40B4-BE49-F238E27FC236}">
-                <a16:creationId xmlns:a16="http://schemas.microsoft.com/office/drawing/2014/main" id="{75C425EE-96F7-D7CF-FF1A-468C65EC0474}"/>
-              </a:ext>
-            </a:extLst>
-          </p:cNvPr>
-          <p:cNvCxnSpPr>
-            <a:cxnSpLocks/>
-          </p:cNvCxnSpPr>
-          <p:nvPr/>
-        </p:nvCxnSpPr>
-        <p:spPr>
-          <a:xfrm flipV="1">
-            <a:off x="821860" y="1999482"/>
-            <a:ext cx="0" cy="2877318"/>
-          </a:xfrm>
-          <a:prstGeom prst="straightConnector1">
-            <a:avLst/>
-          </a:prstGeom>
-          <a:ln w="57150">
-            <a:tailEnd type="triangle"/>
-          </a:ln>
-        </p:spPr>
-        <p:style>
-          <a:lnRef idx="2">
-            <a:schemeClr val="accent1"/>
-          </a:lnRef>
-          <a:fillRef idx="0">
-            <a:schemeClr val="accent1"/>
-          </a:fillRef>
-          <a:effectRef idx="1">
-            <a:schemeClr val="accent1"/>
-          </a:effectRef>
-          <a:fontRef idx="minor">
-            <a:schemeClr val="tx1"/>
-          </a:fontRef>
-        </p:style>
-      </p:cxnSp>
-      <mc:AlternateContent xmlns:mc="http://schemas.openxmlformats.org/markup-compatibility/2006">
-        <mc:Choice xmlns:a14="http://schemas.microsoft.com/office/drawing/2010/main" Requires="a14">
-          <p:sp>
-            <p:nvSpPr>
-              <p:cNvPr id="13" name="TextBox 12">
-                <a:extLst>
-                  <a:ext uri="{FF2B5EF4-FFF2-40B4-BE49-F238E27FC236}">
-                    <a16:creationId xmlns:a16="http://schemas.microsoft.com/office/drawing/2014/main" id="{6B52F6CE-956E-B9B7-285A-6C0742BE3FAC}"/>
-                  </a:ext>
-                </a:extLst>
-              </p:cNvPr>
-              <p:cNvSpPr txBox="1"/>
-              <p:nvPr/>
-            </p:nvSpPr>
-            <p:spPr>
-              <a:xfrm>
-                <a:off x="271786" y="3207308"/>
-                <a:ext cx="608885" cy="461665"/>
-              </a:xfrm>
-              <a:prstGeom prst="rect">
-                <a:avLst/>
-              </a:prstGeom>
-              <a:noFill/>
-            </p:spPr>
-            <p:txBody>
-              <a:bodyPr wrap="none" rtlCol="0">
-                <a:spAutoFit/>
-              </a:bodyPr>
-              <a:lstStyle/>
-              <a:p>
-                <a:pPr/>
-                <a14:m>
-                  <m:oMathPara xmlns:m="http://schemas.openxmlformats.org/officeDocument/2006/math">
-                    <m:oMathParaPr>
-                      <m:jc m:val="centerGroup"/>
-                    </m:oMathParaPr>
-                    <m:oMath xmlns:m="http://schemas.openxmlformats.org/officeDocument/2006/math">
-                      <m:r>
-                        <m:rPr>
-                          <m:sty m:val="p"/>
-                        </m:rPr>
-                        <a:rPr lang="de-DE" sz="2400" dirty="0" smtClean="0">
-                          <a:latin typeface="Cambria Math" panose="02040503050406030204" pitchFamily="18" charset="0"/>
-                        </a:rPr>
-                        <m:t>Δ</m:t>
-                      </m:r>
-                      <m:r>
-                        <a:rPr lang="de-DE" sz="2400" i="1" dirty="0">
-                          <a:latin typeface="Cambria Math" panose="02040503050406030204" pitchFamily="18" charset="0"/>
-                        </a:rPr>
-                        <m:t>𝑓</m:t>
-                      </m:r>
-                    </m:oMath>
-                  </m:oMathPara>
-                </a14:m>
-                <a:endParaRPr lang="de-DE" sz="2400" dirty="0"/>
-              </a:p>
-            </p:txBody>
-          </p:sp>
-        </mc:Choice>
-        <mc:Fallback>
-          <p:sp>
-            <p:nvSpPr>
-              <p:cNvPr id="13" name="TextBox 12">
-                <a:extLst>
-                  <a:ext uri="{FF2B5EF4-FFF2-40B4-BE49-F238E27FC236}">
-                    <a16:creationId xmlns:a16="http://schemas.microsoft.com/office/drawing/2014/main" id="{6B52F6CE-956E-B9B7-285A-6C0742BE3FAC}"/>
-                  </a:ext>
-                </a:extLst>
-              </p:cNvPr>
-              <p:cNvSpPr txBox="1">
-                <a:spLocks noRot="1" noChangeAspect="1" noMove="1" noResize="1" noEditPoints="1" noAdjustHandles="1" noChangeArrowheads="1" noChangeShapeType="1" noTextEdit="1"/>
-              </p:cNvSpPr>
-              <p:nvPr/>
-            </p:nvSpPr>
-            <p:spPr>
-              <a:xfrm>
-                <a:off x="271786" y="3207308"/>
-                <a:ext cx="608885" cy="461665"/>
-              </a:xfrm>
-              <a:prstGeom prst="rect">
-                <a:avLst/>
-              </a:prstGeom>
-              <a:blipFill>
-                <a:blip r:embed="rId3"/>
-                <a:stretch>
-                  <a:fillRect r="-2020" b="-15789"/>
-                </a:stretch>
-              </a:blipFill>
-            </p:spPr>
-            <p:txBody>
-              <a:bodyPr/>
-              <a:lstStyle/>
-              <a:p>
-                <a:r>
-                  <a:rPr lang="de-DE">
-                    <a:noFill/>
-                  </a:rPr>
-                  <a:t> </a:t>
-                </a:r>
-              </a:p>
-            </p:txBody>
-          </p:sp>
-        </mc:Fallback>
-      </mc:AlternateContent>
-      <p:sp>
-        <p:nvSpPr>
-          <p:cNvPr id="15" name="TextBox 14">
-            <a:extLst>
-              <a:ext uri="{FF2B5EF4-FFF2-40B4-BE49-F238E27FC236}">
-                <a16:creationId xmlns:a16="http://schemas.microsoft.com/office/drawing/2014/main" id="{898BD7CD-F3D1-046B-9F2A-9F150D497AA7}"/>
-              </a:ext>
-            </a:extLst>
-          </p:cNvPr>
-          <p:cNvSpPr txBox="1"/>
-          <p:nvPr/>
-        </p:nvSpPr>
-        <p:spPr>
-          <a:xfrm>
-            <a:off x="1584533" y="1480931"/>
-            <a:ext cx="1605119" cy="461665"/>
+            <a:off x="2150590" y="1537817"/>
+            <a:ext cx="1086516" cy="461665"/>
           </a:xfrm>
           <a:prstGeom prst="rect">
             <a:avLst/>
@@ -12278,29 +12947,12 @@
                 <a:latin typeface="Cambria" panose="02040503050406030204" pitchFamily="18" charset="0"/>
                 <a:ea typeface="Cambria" panose="02040503050406030204" pitchFamily="18" charset="0"/>
               </a:rPr>
-              <a:t>Re</a:t>
-            </a:r>
-            <a:r>
-              <a:rPr lang="de-DE" sz="2400" dirty="0">
-                <a:latin typeface="+mj-lt"/>
-                <a:ea typeface="Cambria" panose="02040503050406030204" pitchFamily="18" charset="0"/>
-              </a:rPr>
-              <a:t>(</a:t>
-            </a:r>
-            <a:r>
-              <a:rPr lang="de-DE" sz="2400" dirty="0">
-                <a:latin typeface="Cambria" panose="02040503050406030204" pitchFamily="18" charset="0"/>
-                <a:ea typeface="Cambria" panose="02040503050406030204" pitchFamily="18" charset="0"/>
-              </a:rPr>
               <a:t>kspace</a:t>
             </a:r>
-            <a:r>
-              <a:rPr lang="de-DE" sz="2400" dirty="0">
-                <a:latin typeface="+mj-lt"/>
-                <a:ea typeface="Cambria" panose="02040503050406030204" pitchFamily="18" charset="0"/>
-              </a:rPr>
-              <a:t>)</a:t>
-            </a:r>
+            <a:endParaRPr lang="de-DE" sz="2400" dirty="0">
+              <a:latin typeface="+mj-lt"/>
+              <a:ea typeface="Cambria" panose="02040503050406030204" pitchFamily="18" charset="0"/>
+            </a:endParaRPr>
           </a:p>
         </p:txBody>
       </p:sp>
@@ -12354,53 +13006,12 @@
           </a:p>
         </p:txBody>
       </p:sp>
-      <p:cxnSp>
-        <p:nvCxnSpPr>
-          <p:cNvPr id="19" name="Straight Arrow Connector 18">
-            <a:extLst>
-              <a:ext uri="{FF2B5EF4-FFF2-40B4-BE49-F238E27FC236}">
-                <a16:creationId xmlns:a16="http://schemas.microsoft.com/office/drawing/2014/main" id="{4680B6C4-8920-D2DA-8318-A3EB20F1CFB6}"/>
-              </a:ext>
-            </a:extLst>
-          </p:cNvPr>
-          <p:cNvCxnSpPr>
-            <a:cxnSpLocks/>
-          </p:cNvCxnSpPr>
-          <p:nvPr/>
-        </p:nvCxnSpPr>
-        <p:spPr>
-          <a:xfrm rot="5400000" flipV="1">
-            <a:off x="2470833" y="3641370"/>
-            <a:ext cx="0" cy="2877318"/>
-          </a:xfrm>
-          <a:prstGeom prst="straightConnector1">
-            <a:avLst/>
-          </a:prstGeom>
-          <a:ln w="57150">
-            <a:tailEnd type="triangle"/>
-          </a:ln>
-        </p:spPr>
-        <p:style>
-          <a:lnRef idx="2">
-            <a:schemeClr val="accent1"/>
-          </a:lnRef>
-          <a:fillRef idx="0">
-            <a:schemeClr val="accent1"/>
-          </a:fillRef>
-          <a:effectRef idx="1">
-            <a:schemeClr val="accent1"/>
-          </a:effectRef>
-          <a:fontRef idx="minor">
-            <a:schemeClr val="tx1"/>
-          </a:fontRef>
-        </p:style>
-      </p:cxnSp>
       <p:pic>
         <p:nvPicPr>
-          <p:cNvPr id="25" name="Picture 24" descr="A pixelated image of a black and white square&#10;&#10;AI-generated content may be incorrect.">
-            <a:extLst>
-              <a:ext uri="{FF2B5EF4-FFF2-40B4-BE49-F238E27FC236}">
-                <a16:creationId xmlns:a16="http://schemas.microsoft.com/office/drawing/2014/main" id="{FD90212C-984A-7B7E-A6B1-63CDC0840558}"/>
+          <p:cNvPr id="5" name="Picture 4" descr="A pixelated image of a black and white square&#10;&#10;AI-generated content may be incorrect.">
+            <a:extLst>
+              <a:ext uri="{FF2B5EF4-FFF2-40B4-BE49-F238E27FC236}">
+                <a16:creationId xmlns:a16="http://schemas.microsoft.com/office/drawing/2014/main" id="{2EB070E9-3B75-C8E5-036B-7400DACD2016}"/>
               </a:ext>
             </a:extLst>
           </p:cNvPr>
@@ -12417,15 +13028,14 @@
               </a:ext>
             </a:extLst>
           </a:blip>
-          <a:srcRect l="8882" t="-10182" r="-8882" b="10182"/>
           <a:stretch>
             <a:fillRect/>
           </a:stretch>
         </p:blipFill>
         <p:spPr>
           <a:xfrm>
-            <a:off x="896576" y="1726299"/>
-            <a:ext cx="3236983" cy="3236983"/>
+            <a:off x="786032" y="2073396"/>
+            <a:ext cx="3336000" cy="3336000"/>
           </a:xfrm>
           <a:prstGeom prst="rect">
             <a:avLst/>
@@ -12445,7 +13055,7 @@
 </p:sld>
 </file>
 
-<file path=ppt/slides/slide2.xml><?xml version="1.0" encoding="utf-8"?>
+<file path=ppt/slides/slide3.xml><?xml version="1.0" encoding="utf-8"?>
 <p:sld xmlns:a="http://schemas.openxmlformats.org/drawingml/2006/main" xmlns:r="http://schemas.openxmlformats.org/officeDocument/2006/relationships" xmlns:p="http://schemas.openxmlformats.org/presentationml/2006/main">
   <p:cSld>
     <p:spTree>
@@ -17026,7 +17636,7 @@
 </p:sld>
 </file>
 
-<file path=ppt/slides/slide3.xml><?xml version="1.0" encoding="utf-8"?>
+<file path=ppt/slides/slide4.xml><?xml version="1.0" encoding="utf-8"?>
 <p:sld xmlns:a="http://schemas.openxmlformats.org/drawingml/2006/main" xmlns:r="http://schemas.openxmlformats.org/officeDocument/2006/relationships" xmlns:p="http://schemas.openxmlformats.org/presentationml/2006/main">
   <p:cSld>
     <p:spTree>
@@ -17643,7 +18253,7 @@
 </p:sld>
 </file>
 
-<file path=ppt/slides/slide4.xml><?xml version="1.0" encoding="utf-8"?>
+<file path=ppt/slides/slide5.xml><?xml version="1.0" encoding="utf-8"?>
 <p:sld xmlns:a="http://schemas.openxmlformats.org/drawingml/2006/main" xmlns:r="http://schemas.openxmlformats.org/officeDocument/2006/relationships" xmlns:p="http://schemas.openxmlformats.org/presentationml/2006/main">
   <p:cSld>
     <p:spTree>
@@ -17781,7 +18391,7 @@
 </p:sld>
 </file>
 
-<file path=ppt/slides/slide5.xml><?xml version="1.0" encoding="utf-8"?>
+<file path=ppt/slides/slide6.xml><?xml version="1.0" encoding="utf-8"?>
 <p:sld xmlns:a="http://schemas.openxmlformats.org/drawingml/2006/main" xmlns:r="http://schemas.openxmlformats.org/officeDocument/2006/relationships" xmlns:p="http://schemas.openxmlformats.org/presentationml/2006/main">
   <p:cSld>
     <p:spTree>
@@ -18121,7 +18731,7 @@
 </p:sld>
 </file>
 
-<file path=ppt/slides/slide6.xml><?xml version="1.0" encoding="utf-8"?>
+<file path=ppt/slides/slide7.xml><?xml version="1.0" encoding="utf-8"?>
 <p:sld xmlns:a="http://schemas.openxmlformats.org/drawingml/2006/main" xmlns:r="http://schemas.openxmlformats.org/officeDocument/2006/relationships" xmlns:p="http://schemas.openxmlformats.org/presentationml/2006/main">
   <p:cSld>
     <p:spTree>
@@ -18231,7 +18841,7 @@
 </p:sld>
 </file>
 
-<file path=ppt/slides/slide7.xml><?xml version="1.0" encoding="utf-8"?>
+<file path=ppt/slides/slide8.xml><?xml version="1.0" encoding="utf-8"?>
 <p:sld xmlns:a="http://schemas.openxmlformats.org/drawingml/2006/main" xmlns:r="http://schemas.openxmlformats.org/officeDocument/2006/relationships" xmlns:p="http://schemas.openxmlformats.org/presentationml/2006/main">
   <p:cSld>
     <p:spTree>
@@ -18334,7 +18944,7 @@
 </p:sld>
 </file>
 
-<file path=ppt/slides/slide8.xml><?xml version="1.0" encoding="utf-8"?>
+<file path=ppt/slides/slide9.xml><?xml version="1.0" encoding="utf-8"?>
 <p:sld xmlns:a="http://schemas.openxmlformats.org/drawingml/2006/main" xmlns:r="http://schemas.openxmlformats.org/officeDocument/2006/relationships" xmlns:p="http://schemas.openxmlformats.org/presentationml/2006/main">
   <p:cSld>
     <p:spTree>
@@ -18627,420 +19237,6 @@
     <p:extLst>
       <p:ext uri="{BB962C8B-B14F-4D97-AF65-F5344CB8AC3E}">
         <p14:creationId xmlns:p14="http://schemas.microsoft.com/office/powerpoint/2010/main" val="1739966096"/>
-      </p:ext>
-    </p:extLst>
-  </p:cSld>
-  <p:clrMapOvr>
-    <a:masterClrMapping/>
-  </p:clrMapOvr>
-</p:sld>
-</file>
-
-<file path=ppt/slides/slide9.xml><?xml version="1.0" encoding="utf-8"?>
-<p:sld xmlns:a="http://schemas.openxmlformats.org/drawingml/2006/main" xmlns:r="http://schemas.openxmlformats.org/officeDocument/2006/relationships" xmlns:p="http://schemas.openxmlformats.org/presentationml/2006/main">
-  <p:cSld>
-    <p:spTree>
-      <p:nvGrpSpPr>
-        <p:cNvPr id="1" name=""/>
-        <p:cNvGrpSpPr/>
-        <p:nvPr/>
-      </p:nvGrpSpPr>
-      <p:grpSpPr>
-        <a:xfrm>
-          <a:off x="0" y="0"/>
-          <a:ext cx="0" cy="0"/>
-          <a:chOff x="0" y="0"/>
-          <a:chExt cx="0" cy="0"/>
-        </a:xfrm>
-      </p:grpSpPr>
-      <p:pic>
-        <p:nvPicPr>
-          <p:cNvPr id="10" name="Picture 9" descr="A pixelated image of a black and white square&#10;&#10;AI-generated content may be incorrect.">
-            <a:extLst>
-              <a:ext uri="{FF2B5EF4-FFF2-40B4-BE49-F238E27FC236}">
-                <a16:creationId xmlns:a16="http://schemas.microsoft.com/office/drawing/2014/main" id="{B00E4B1B-AE6F-5FDD-28BE-D8CB9C4A2F2D}"/>
-              </a:ext>
-            </a:extLst>
-          </p:cNvPr>
-          <p:cNvPicPr>
-            <a:picLocks noChangeAspect="1"/>
-          </p:cNvPicPr>
-          <p:nvPr/>
-        </p:nvPicPr>
-        <p:blipFill>
-          <a:blip r:embed="rId2">
-            <a:extLst>
-              <a:ext uri="{28A0092B-C50C-407E-A947-70E740481C1C}">
-                <a14:useLocalDpi xmlns:a14="http://schemas.microsoft.com/office/drawing/2010/main" val="0"/>
-              </a:ext>
-            </a:extLst>
-          </a:blip>
-          <a:stretch>
-            <a:fillRect/>
-          </a:stretch>
-        </p:blipFill>
-        <p:spPr>
-          <a:xfrm>
-            <a:off x="708053" y="218154"/>
-            <a:ext cx="3236983" cy="3236983"/>
-          </a:xfrm>
-          <a:prstGeom prst="rect">
-            <a:avLst/>
-          </a:prstGeom>
-        </p:spPr>
-      </p:pic>
-      <p:pic>
-        <p:nvPicPr>
-          <p:cNvPr id="13" name="Picture 12" descr="A black and white pixelated square&#10;&#10;AI-generated content may be incorrect.">
-            <a:extLst>
-              <a:ext uri="{FF2B5EF4-FFF2-40B4-BE49-F238E27FC236}">
-                <a16:creationId xmlns:a16="http://schemas.microsoft.com/office/drawing/2014/main" id="{0D9ADA81-E905-3774-D2CB-634192A29A61}"/>
-              </a:ext>
-            </a:extLst>
-          </p:cNvPr>
-          <p:cNvPicPr>
-            <a:picLocks noChangeAspect="1"/>
-          </p:cNvPicPr>
-          <p:nvPr/>
-        </p:nvPicPr>
-        <p:blipFill>
-          <a:blip r:embed="rId3">
-            <a:extLst>
-              <a:ext uri="{28A0092B-C50C-407E-A947-70E740481C1C}">
-                <a14:useLocalDpi xmlns:a14="http://schemas.microsoft.com/office/drawing/2010/main" val="0"/>
-              </a:ext>
-            </a:extLst>
-          </a:blip>
-          <a:stretch>
-            <a:fillRect/>
-          </a:stretch>
-        </p:blipFill>
-        <p:spPr>
-          <a:xfrm>
-            <a:off x="4164522" y="218154"/>
-            <a:ext cx="3236983" cy="3236983"/>
-          </a:xfrm>
-          <a:prstGeom prst="rect">
-            <a:avLst/>
-          </a:prstGeom>
-        </p:spPr>
-      </p:pic>
-      <p:pic>
-        <p:nvPicPr>
-          <p:cNvPr id="16" name="Picture 15" descr="A pixelated image of a black and white square&#10;&#10;AI-generated content may be incorrect.">
-            <a:extLst>
-              <a:ext uri="{FF2B5EF4-FFF2-40B4-BE49-F238E27FC236}">
-                <a16:creationId xmlns:a16="http://schemas.microsoft.com/office/drawing/2014/main" id="{3B6F989A-506C-5077-5884-4F94D607A125}"/>
-              </a:ext>
-            </a:extLst>
-          </p:cNvPr>
-          <p:cNvPicPr>
-            <a:picLocks noChangeAspect="1"/>
-          </p:cNvPicPr>
-          <p:nvPr/>
-        </p:nvPicPr>
-        <p:blipFill>
-          <a:blip r:embed="rId4">
-            <a:extLst>
-              <a:ext uri="{28A0092B-C50C-407E-A947-70E740481C1C}">
-                <a14:useLocalDpi xmlns:a14="http://schemas.microsoft.com/office/drawing/2010/main" val="0"/>
-              </a:ext>
-            </a:extLst>
-          </a:blip>
-          <a:stretch>
-            <a:fillRect/>
-          </a:stretch>
-        </p:blipFill>
-        <p:spPr>
-          <a:xfrm>
-            <a:off x="7620991" y="218154"/>
-            <a:ext cx="3236983" cy="3236983"/>
-          </a:xfrm>
-          <a:prstGeom prst="rect">
-            <a:avLst/>
-          </a:prstGeom>
-        </p:spPr>
-      </p:pic>
-      <p:pic>
-        <p:nvPicPr>
-          <p:cNvPr id="19" name="Picture 18" descr="A pixelated image of a black and white square&#10;&#10;AI-generated content may be incorrect.">
-            <a:extLst>
-              <a:ext uri="{FF2B5EF4-FFF2-40B4-BE49-F238E27FC236}">
-                <a16:creationId xmlns:a16="http://schemas.microsoft.com/office/drawing/2014/main" id="{1EBEE43C-540D-D316-5FA5-A944A41C619B}"/>
-              </a:ext>
-            </a:extLst>
-          </p:cNvPr>
-          <p:cNvPicPr>
-            <a:picLocks noChangeAspect="1"/>
-          </p:cNvPicPr>
-          <p:nvPr/>
-        </p:nvPicPr>
-        <p:blipFill>
-          <a:blip r:embed="rId5">
-            <a:extLst>
-              <a:ext uri="{28A0092B-C50C-407E-A947-70E740481C1C}">
-                <a14:useLocalDpi xmlns:a14="http://schemas.microsoft.com/office/drawing/2010/main" val="0"/>
-              </a:ext>
-            </a:extLst>
-          </a:blip>
-          <a:stretch>
-            <a:fillRect/>
-          </a:stretch>
-        </p:blipFill>
-        <p:spPr>
-          <a:xfrm>
-            <a:off x="708053" y="3557884"/>
-            <a:ext cx="3236983" cy="3236983"/>
-          </a:xfrm>
-          <a:prstGeom prst="rect">
-            <a:avLst/>
-          </a:prstGeom>
-        </p:spPr>
-      </p:pic>
-      <p:pic>
-        <p:nvPicPr>
-          <p:cNvPr id="21" name="Picture 20" descr="A black and white pixelated square&#10;&#10;AI-generated content may be incorrect.">
-            <a:extLst>
-              <a:ext uri="{FF2B5EF4-FFF2-40B4-BE49-F238E27FC236}">
-                <a16:creationId xmlns:a16="http://schemas.microsoft.com/office/drawing/2014/main" id="{D4D3CA93-3979-3975-8734-1FC1A4FF1BEA}"/>
-              </a:ext>
-            </a:extLst>
-          </p:cNvPr>
-          <p:cNvPicPr>
-            <a:picLocks noChangeAspect="1"/>
-          </p:cNvPicPr>
-          <p:nvPr/>
-        </p:nvPicPr>
-        <p:blipFill>
-          <a:blip r:embed="rId6">
-            <a:extLst>
-              <a:ext uri="{28A0092B-C50C-407E-A947-70E740481C1C}">
-                <a14:useLocalDpi xmlns:a14="http://schemas.microsoft.com/office/drawing/2010/main" val="0"/>
-              </a:ext>
-            </a:extLst>
-          </a:blip>
-          <a:stretch>
-            <a:fillRect/>
-          </a:stretch>
-        </p:blipFill>
-        <p:spPr>
-          <a:xfrm>
-            <a:off x="4164522" y="3557884"/>
-            <a:ext cx="3236983" cy="3236983"/>
-          </a:xfrm>
-          <a:prstGeom prst="rect">
-            <a:avLst/>
-          </a:prstGeom>
-        </p:spPr>
-      </p:pic>
-      <p:pic>
-        <p:nvPicPr>
-          <p:cNvPr id="27" name="Picture 26" descr="A pixelated image of a black and white square&#10;&#10;AI-generated content may be incorrect.">
-            <a:extLst>
-              <a:ext uri="{FF2B5EF4-FFF2-40B4-BE49-F238E27FC236}">
-                <a16:creationId xmlns:a16="http://schemas.microsoft.com/office/drawing/2014/main" id="{3B148123-512C-4CE9-AB62-6D6BE6ECD6F0}"/>
-              </a:ext>
-            </a:extLst>
-          </p:cNvPr>
-          <p:cNvPicPr>
-            <a:picLocks noChangeAspect="1"/>
-          </p:cNvPicPr>
-          <p:nvPr/>
-        </p:nvPicPr>
-        <p:blipFill>
-          <a:blip r:embed="rId7">
-            <a:extLst>
-              <a:ext uri="{28A0092B-C50C-407E-A947-70E740481C1C}">
-                <a14:useLocalDpi xmlns:a14="http://schemas.microsoft.com/office/drawing/2010/main" val="0"/>
-              </a:ext>
-            </a:extLst>
-          </a:blip>
-          <a:stretch>
-            <a:fillRect/>
-          </a:stretch>
-        </p:blipFill>
-        <p:spPr>
-          <a:xfrm>
-            <a:off x="7620991" y="3557884"/>
-            <a:ext cx="3236983" cy="3236983"/>
-          </a:xfrm>
-          <a:prstGeom prst="rect">
-            <a:avLst/>
-          </a:prstGeom>
-        </p:spPr>
-      </p:pic>
-      <p:cxnSp>
-        <p:nvCxnSpPr>
-          <p:cNvPr id="22" name="Straight Connector 21">
-            <a:extLst>
-              <a:ext uri="{FF2B5EF4-FFF2-40B4-BE49-F238E27FC236}">
-                <a16:creationId xmlns:a16="http://schemas.microsoft.com/office/drawing/2014/main" id="{A6298A49-1BB8-B363-5568-E3DD75F7D688}"/>
-              </a:ext>
-            </a:extLst>
-          </p:cNvPr>
-          <p:cNvCxnSpPr/>
-          <p:nvPr/>
-        </p:nvCxnSpPr>
-        <p:spPr>
-          <a:xfrm>
-            <a:off x="7867853" y="3484520"/>
-            <a:ext cx="3198657" cy="2971800"/>
-          </a:xfrm>
-          <a:prstGeom prst="line">
-            <a:avLst/>
-          </a:prstGeom>
-          <a:ln w="76200">
-            <a:solidFill>
-              <a:srgbClr val="FF0000"/>
-            </a:solidFill>
-          </a:ln>
-        </p:spPr>
-        <p:style>
-          <a:lnRef idx="2">
-            <a:schemeClr val="accent1"/>
-          </a:lnRef>
-          <a:fillRef idx="0">
-            <a:schemeClr val="accent1"/>
-          </a:fillRef>
-          <a:effectRef idx="1">
-            <a:schemeClr val="accent1"/>
-          </a:effectRef>
-          <a:fontRef idx="minor">
-            <a:schemeClr val="tx1"/>
-          </a:fontRef>
-        </p:style>
-      </p:cxnSp>
-      <p:cxnSp>
-        <p:nvCxnSpPr>
-          <p:cNvPr id="23" name="Straight Connector 22">
-            <a:extLst>
-              <a:ext uri="{FF2B5EF4-FFF2-40B4-BE49-F238E27FC236}">
-                <a16:creationId xmlns:a16="http://schemas.microsoft.com/office/drawing/2014/main" id="{6423B773-293E-5CF2-720C-FBB70CF0E5F1}"/>
-              </a:ext>
-            </a:extLst>
-          </p:cNvPr>
-          <p:cNvCxnSpPr>
-            <a:cxnSpLocks/>
-          </p:cNvCxnSpPr>
-          <p:nvPr/>
-        </p:nvCxnSpPr>
-        <p:spPr>
-          <a:xfrm rot="16200000">
-            <a:off x="7867853" y="3484520"/>
-            <a:ext cx="3198657" cy="2971800"/>
-          </a:xfrm>
-          <a:prstGeom prst="line">
-            <a:avLst/>
-          </a:prstGeom>
-          <a:ln w="76200">
-            <a:solidFill>
-              <a:srgbClr val="FF0000"/>
-            </a:solidFill>
-          </a:ln>
-        </p:spPr>
-        <p:style>
-          <a:lnRef idx="2">
-            <a:schemeClr val="accent1"/>
-          </a:lnRef>
-          <a:fillRef idx="0">
-            <a:schemeClr val="accent1"/>
-          </a:fillRef>
-          <a:effectRef idx="1">
-            <a:schemeClr val="accent1"/>
-          </a:effectRef>
-          <a:fontRef idx="minor">
-            <a:schemeClr val="tx1"/>
-          </a:fontRef>
-        </p:style>
-      </p:cxnSp>
-      <p:cxnSp>
-        <p:nvCxnSpPr>
-          <p:cNvPr id="25" name="Straight Connector 24">
-            <a:extLst>
-              <a:ext uri="{FF2B5EF4-FFF2-40B4-BE49-F238E27FC236}">
-                <a16:creationId xmlns:a16="http://schemas.microsoft.com/office/drawing/2014/main" id="{51EA2EBE-D20B-513E-1CAA-42EBA9E82B01}"/>
-              </a:ext>
-            </a:extLst>
-          </p:cNvPr>
-          <p:cNvCxnSpPr/>
-          <p:nvPr/>
-        </p:nvCxnSpPr>
-        <p:spPr>
-          <a:xfrm>
-            <a:off x="4485605" y="3542429"/>
-            <a:ext cx="3198657" cy="2971800"/>
-          </a:xfrm>
-          <a:prstGeom prst="line">
-            <a:avLst/>
-          </a:prstGeom>
-          <a:ln w="76200">
-            <a:solidFill>
-              <a:srgbClr val="FF0000"/>
-            </a:solidFill>
-          </a:ln>
-        </p:spPr>
-        <p:style>
-          <a:lnRef idx="2">
-            <a:schemeClr val="accent1"/>
-          </a:lnRef>
-          <a:fillRef idx="0">
-            <a:schemeClr val="accent1"/>
-          </a:fillRef>
-          <a:effectRef idx="1">
-            <a:schemeClr val="accent1"/>
-          </a:effectRef>
-          <a:fontRef idx="minor">
-            <a:schemeClr val="tx1"/>
-          </a:fontRef>
-        </p:style>
-      </p:cxnSp>
-      <p:cxnSp>
-        <p:nvCxnSpPr>
-          <p:cNvPr id="26" name="Straight Connector 25">
-            <a:extLst>
-              <a:ext uri="{FF2B5EF4-FFF2-40B4-BE49-F238E27FC236}">
-                <a16:creationId xmlns:a16="http://schemas.microsoft.com/office/drawing/2014/main" id="{199B7127-BAFE-9900-00F5-A3FFC7259493}"/>
-              </a:ext>
-            </a:extLst>
-          </p:cNvPr>
-          <p:cNvCxnSpPr>
-            <a:cxnSpLocks/>
-          </p:cNvCxnSpPr>
-          <p:nvPr/>
-        </p:nvCxnSpPr>
-        <p:spPr>
-          <a:xfrm rot="16200000">
-            <a:off x="4485605" y="3542429"/>
-            <a:ext cx="3198657" cy="2971800"/>
-          </a:xfrm>
-          <a:prstGeom prst="line">
-            <a:avLst/>
-          </a:prstGeom>
-          <a:ln w="76200">
-            <a:solidFill>
-              <a:srgbClr val="FF0000"/>
-            </a:solidFill>
-          </a:ln>
-        </p:spPr>
-        <p:style>
-          <a:lnRef idx="2">
-            <a:schemeClr val="accent1"/>
-          </a:lnRef>
-          <a:fillRef idx="0">
-            <a:schemeClr val="accent1"/>
-          </a:fillRef>
-          <a:effectRef idx="1">
-            <a:schemeClr val="accent1"/>
-          </a:effectRef>
-          <a:fontRef idx="minor">
-            <a:schemeClr val="tx1"/>
-          </a:fontRef>
-        </p:style>
-      </p:cxnSp>
-    </p:spTree>
-    <p:extLst>
-      <p:ext uri="{BB962C8B-B14F-4D97-AF65-F5344CB8AC3E}">
-        <p14:creationId xmlns:p14="http://schemas.microsoft.com/office/powerpoint/2010/main" val="3134903272"/>
       </p:ext>
     </p:extLst>
   </p:cSld>

</xml_diff>